<commit_message>
updated presentation and webpage body layout
</commit_message>
<xml_diff>
--- a/cloud_cicd.pptx
+++ b/cloud_cicd.pptx
@@ -5,23 +5,22 @@
     <p:sldMasterId id="2147483648" r:id="rId1"/>
   </p:sldMasterIdLst>
   <p:notesMasterIdLst>
-    <p:notesMasterId r:id="rId16"/>
+    <p:notesMasterId r:id="rId15"/>
   </p:notesMasterIdLst>
   <p:sldIdLst>
     <p:sldId id="256" r:id="rId2"/>
     <p:sldId id="257" r:id="rId3"/>
     <p:sldId id="258" r:id="rId4"/>
-    <p:sldId id="259" r:id="rId5"/>
-    <p:sldId id="260" r:id="rId6"/>
-    <p:sldId id="261" r:id="rId7"/>
-    <p:sldId id="262" r:id="rId8"/>
-    <p:sldId id="263" r:id="rId9"/>
-    <p:sldId id="264" r:id="rId10"/>
-    <p:sldId id="265" r:id="rId11"/>
-    <p:sldId id="266" r:id="rId12"/>
-    <p:sldId id="267" r:id="rId13"/>
-    <p:sldId id="268" r:id="rId14"/>
-    <p:sldId id="269" r:id="rId15"/>
+    <p:sldId id="260" r:id="rId5"/>
+    <p:sldId id="261" r:id="rId6"/>
+    <p:sldId id="262" r:id="rId7"/>
+    <p:sldId id="263" r:id="rId8"/>
+    <p:sldId id="264" r:id="rId9"/>
+    <p:sldId id="265" r:id="rId10"/>
+    <p:sldId id="266" r:id="rId11"/>
+    <p:sldId id="267" r:id="rId12"/>
+    <p:sldId id="268" r:id="rId13"/>
+    <p:sldId id="269" r:id="rId14"/>
   </p:sldIdLst>
   <p:sldSz cx="9144000" cy="5143500" type="screen16x9"/>
   <p:notesSz cx="5143500" cy="9144000"/>
@@ -670,90 +669,6 @@
 </p:notes>
 </file>
 
-<file path=ppt/notesSlides/notesSlide14.xml><?xml version="1.0" encoding="utf-8"?>
-<p:notes xmlns:a="http://schemas.openxmlformats.org/drawingml/2006/main" xmlns:r="http://schemas.openxmlformats.org/officeDocument/2006/relationships" xmlns:p="http://schemas.openxmlformats.org/presentationml/2006/main">
-  <p:cSld>
-    <p:spTree>
-      <p:nvGrpSpPr>
-        <p:cNvPr id="1" name=""/>
-        <p:cNvGrpSpPr/>
-        <p:nvPr/>
-      </p:nvGrpSpPr>
-      <p:grpSpPr>
-        <a:xfrm>
-          <a:off x="0" y="0"/>
-          <a:ext cx="0" cy="0"/>
-          <a:chOff x="0" y="0"/>
-          <a:chExt cx="0" cy="0"/>
-        </a:xfrm>
-      </p:grpSpPr>
-      <p:sp>
-        <p:nvSpPr>
-          <p:cNvPr id="2" name="Slide Image Placeholder 1"/>
-          <p:cNvSpPr>
-            <a:spLocks noGrp="1" noRot="1" noChangeAspect="1"/>
-          </p:cNvSpPr>
-          <p:nvPr>
-            <p:ph type="sldImg"/>
-          </p:nvPr>
-        </p:nvSpPr>
-        <p:spPr/>
-      </p:sp>
-      <p:sp>
-        <p:nvSpPr>
-          <p:cNvPr id="3" name="Notes Placeholder 2"/>
-          <p:cNvSpPr>
-            <a:spLocks noGrp="1"/>
-          </p:cNvSpPr>
-          <p:nvPr>
-            <p:ph type="body" idx="1"/>
-          </p:nvPr>
-        </p:nvSpPr>
-        <p:spPr/>
-        <p:txBody>
-          <a:bodyPr/>
-          <a:lstStyle/>
-          <a:p>
-            <a:endParaRPr lang="en-US" dirty="0"/>
-          </a:p>
-        </p:txBody>
-      </p:sp>
-      <p:sp>
-        <p:nvSpPr>
-          <p:cNvPr id="4" name="Slide Number Placeholder 3"/>
-          <p:cNvSpPr>
-            <a:spLocks noGrp="1"/>
-          </p:cNvSpPr>
-          <p:nvPr>
-            <p:ph type="sldNum" sz="quarter" idx="10"/>
-          </p:nvPr>
-        </p:nvSpPr>
-        <p:spPr/>
-        <p:txBody>
-          <a:bodyPr/>
-          <a:lstStyle/>
-          <a:p>
-            <a:fld id="{F7021451-1387-4CA6-816F-3879F97B5CBC}" type="slidenum">
-              <a:rPr lang="en-US"/>
-              <a:t>14</a:t>
-            </a:fld>
-            <a:endParaRPr lang="en-US"/>
-          </a:p>
-        </p:txBody>
-      </p:sp>
-    </p:spTree>
-    <p:extLst>
-      <p:ext uri="{BB962C8B-B14F-4D97-AF65-F5344CB8AC3E}">
-        <p14:creationId xmlns:p14="http://schemas.microsoft.com/office/powerpoint/2010/main" val="1024086991"/>
-      </p:ext>
-    </p:extLst>
-  </p:cSld>
-  <p:clrMapOvr>
-    <a:masterClrMapping/>
-  </p:clrMapOvr>
-</p:notes>
-</file>
-
 <file path=ppt/notesSlides/notesSlide2.xml><?xml version="1.0" encoding="utf-8"?>
 <p:notes xmlns:a="http://schemas.openxmlformats.org/drawingml/2006/main" xmlns:r="http://schemas.openxmlformats.org/officeDocument/2006/relationships" xmlns:p="http://schemas.openxmlformats.org/presentationml/2006/main">
   <p:cSld>
@@ -2414,1146 +2329,6 @@
 
 <file path=ppt/slides/slide10.xml><?xml version="1.0" encoding="utf-8"?>
 <p:sld xmlns:a="http://schemas.openxmlformats.org/drawingml/2006/main" xmlns:r="http://schemas.openxmlformats.org/officeDocument/2006/relationships" xmlns:p="http://schemas.openxmlformats.org/presentationml/2006/main">
-  <p:cSld name="Slide 10">
-    <p:bg>
-      <p:bgPr>
-        <a:solidFill>
-          <a:srgbClr val="F4F8FC"/>
-        </a:solidFill>
-        <a:effectLst/>
-      </p:bgPr>
-    </p:bg>
-    <p:spTree>
-      <p:nvGrpSpPr>
-        <p:cNvPr id="1" name=""/>
-        <p:cNvGrpSpPr/>
-        <p:nvPr/>
-      </p:nvGrpSpPr>
-      <p:grpSpPr>
-        <a:xfrm>
-          <a:off x="0" y="0"/>
-          <a:ext cx="0" cy="0"/>
-          <a:chOff x="0" y="0"/>
-          <a:chExt cx="0" cy="0"/>
-        </a:xfrm>
-      </p:grpSpPr>
-      <p:sp>
-        <p:nvSpPr>
-          <p:cNvPr id="2" name="Shape 0"/>
-          <p:cNvSpPr/>
-          <p:nvPr/>
-        </p:nvSpPr>
-        <p:spPr>
-          <a:xfrm>
-            <a:off x="0" y="0"/>
-            <a:ext cx="9144000" cy="1005840"/>
-          </a:xfrm>
-          <a:prstGeom prst="rect">
-            <a:avLst/>
-          </a:prstGeom>
-          <a:solidFill>
-            <a:srgbClr val="0D1B2A"/>
-          </a:solidFill>
-          <a:ln w="12700">
-            <a:solidFill>
-              <a:srgbClr val="0D1B2A"/>
-            </a:solidFill>
-            <a:prstDash val="solid"/>
-          </a:ln>
-        </p:spPr>
-      </p:sp>
-      <p:sp>
-        <p:nvSpPr>
-          <p:cNvPr id="3" name="Shape 1"/>
-          <p:cNvSpPr/>
-          <p:nvPr/>
-        </p:nvSpPr>
-        <p:spPr>
-          <a:xfrm>
-            <a:off x="0" y="960120"/>
-            <a:ext cx="9144000" cy="45720"/>
-          </a:xfrm>
-          <a:prstGeom prst="rect">
-            <a:avLst/>
-          </a:prstGeom>
-          <a:solidFill>
-            <a:srgbClr val="2196F3"/>
-          </a:solidFill>
-          <a:ln w="12700">
-            <a:solidFill>
-              <a:srgbClr val="2196F3"/>
-            </a:solidFill>
-            <a:prstDash val="solid"/>
-          </a:ln>
-        </p:spPr>
-      </p:sp>
-      <p:sp>
-        <p:nvSpPr>
-          <p:cNvPr id="4" name="Text 2"/>
-          <p:cNvSpPr/>
-          <p:nvPr/>
-        </p:nvSpPr>
-        <p:spPr>
-          <a:xfrm>
-            <a:off x="411480" y="109728"/>
-            <a:ext cx="7315200" cy="548640"/>
-          </a:xfrm>
-          <a:prstGeom prst="rect">
-            <a:avLst/>
-          </a:prstGeom>
-          <a:noFill/>
-          <a:ln/>
-        </p:spPr>
-        <p:txBody>
-          <a:bodyPr wrap="square" lIns="0" tIns="0" rIns="0" bIns="0" rtlCol="0" anchor="ctr"/>
-          <a:lstStyle/>
-          <a:p>
-            <a:pPr marL="0" indent="0">
-              <a:buNone/>
-            </a:pPr>
-            <a:r>
-              <a:rPr lang="en-US" sz="2600" b="1" dirty="0">
-                <a:solidFill>
-                  <a:srgbClr val="FFFFFF"/>
-                </a:solidFill>
-                <a:latin typeface="Calibri" pitchFamily="34" charset="0"/>
-                <a:ea typeface="Calibri" pitchFamily="34" charset="-122"/>
-                <a:cs typeface="Calibri" pitchFamily="34" charset="-120"/>
-              </a:rPr>
-              <a:t>06 · Orchestration — Cluster K3s</a:t>
-            </a:r>
-            <a:endParaRPr lang="en-US" sz="2600" dirty="0"/>
-          </a:p>
-        </p:txBody>
-      </p:sp>
-      <p:sp>
-        <p:nvSpPr>
-          <p:cNvPr id="5" name="Text 3"/>
-          <p:cNvSpPr/>
-          <p:nvPr/>
-        </p:nvSpPr>
-        <p:spPr>
-          <a:xfrm>
-            <a:off x="411480" y="594360"/>
-            <a:ext cx="7315200" cy="347472"/>
-          </a:xfrm>
-          <a:prstGeom prst="rect">
-            <a:avLst/>
-          </a:prstGeom>
-          <a:noFill/>
-          <a:ln/>
-        </p:spPr>
-        <p:txBody>
-          <a:bodyPr wrap="square" lIns="0" tIns="0" rIns="0" bIns="0" rtlCol="0" anchor="ctr"/>
-          <a:lstStyle/>
-          <a:p>
-            <a:pPr marL="0" indent="0">
-              <a:buNone/>
-            </a:pPr>
-            <a:r>
-              <a:rPr lang="en-US" sz="1300" i="1" dirty="0">
-                <a:solidFill>
-                  <a:srgbClr val="90CAF9"/>
-                </a:solidFill>
-                <a:latin typeface="Calibri" pitchFamily="34" charset="0"/>
-                <a:ea typeface="Calibri" pitchFamily="34" charset="-122"/>
-                <a:cs typeface="Calibri" pitchFamily="34" charset="-120"/>
-              </a:rPr>
-              <a:t>Déploiement Kubernetes léger : Master + Worker, pods et exposition NodePort</a:t>
-            </a:r>
-            <a:endParaRPr lang="en-US" sz="1300" dirty="0"/>
-          </a:p>
-        </p:txBody>
-      </p:sp>
-      <p:sp>
-        <p:nvSpPr>
-          <p:cNvPr id="6" name="Shape 4"/>
-          <p:cNvSpPr/>
-          <p:nvPr/>
-        </p:nvSpPr>
-        <p:spPr>
-          <a:xfrm>
-            <a:off x="320040" y="1188720"/>
-            <a:ext cx="5029200" cy="749808"/>
-          </a:xfrm>
-          <a:prstGeom prst="rect">
-            <a:avLst/>
-          </a:prstGeom>
-          <a:solidFill>
-            <a:srgbClr val="FFFFFF"/>
-          </a:solidFill>
-          <a:ln w="12700">
-            <a:solidFill>
-              <a:srgbClr val="BFDBFE"/>
-            </a:solidFill>
-            <a:prstDash val="solid"/>
-          </a:ln>
-          <a:effectLst>
-            <a:outerShdw blurRad="101600" dist="25400" dir="8100000" algn="bl" rotWithShape="0">
-              <a:srgbClr val="000000">
-                <a:alpha val="10000"/>
-              </a:srgbClr>
-            </a:outerShdw>
-          </a:effectLst>
-        </p:spPr>
-      </p:sp>
-      <p:sp>
-        <p:nvSpPr>
-          <p:cNvPr id="7" name="Shape 5"/>
-          <p:cNvSpPr/>
-          <p:nvPr/>
-        </p:nvSpPr>
-        <p:spPr>
-          <a:xfrm>
-            <a:off x="320040" y="1188720"/>
-            <a:ext cx="64008" cy="749808"/>
-          </a:xfrm>
-          <a:prstGeom prst="rect">
-            <a:avLst/>
-          </a:prstGeom>
-          <a:solidFill>
-            <a:srgbClr val="326CE5"/>
-          </a:solidFill>
-          <a:ln w="12700">
-            <a:solidFill>
-              <a:srgbClr val="326CE5"/>
-            </a:solidFill>
-            <a:prstDash val="solid"/>
-          </a:ln>
-        </p:spPr>
-      </p:sp>
-      <p:sp>
-        <p:nvSpPr>
-          <p:cNvPr id="8" name="Text 6"/>
-          <p:cNvSpPr/>
-          <p:nvPr/>
-        </p:nvSpPr>
-        <p:spPr>
-          <a:xfrm>
-            <a:off x="548640" y="1234440"/>
-            <a:ext cx="4663440" cy="274320"/>
-          </a:xfrm>
-          <a:prstGeom prst="rect">
-            <a:avLst/>
-          </a:prstGeom>
-          <a:noFill/>
-          <a:ln/>
-        </p:spPr>
-        <p:txBody>
-          <a:bodyPr wrap="square" lIns="0" tIns="0" rIns="0" bIns="0" rtlCol="0" anchor="ctr"/>
-          <a:lstStyle/>
-          <a:p>
-            <a:pPr marL="0" indent="0">
-              <a:buNone/>
-            </a:pPr>
-            <a:r>
-              <a:rPr lang="en-US" sz="1250" b="1" dirty="0">
-                <a:solidFill>
-                  <a:srgbClr val="1E293B"/>
-                </a:solidFill>
-                <a:latin typeface="Calibri" pitchFamily="34" charset="0"/>
-                <a:ea typeface="Calibri" pitchFamily="34" charset="-122"/>
-                <a:cs typeface="Calibri" pitchFamily="34" charset="-120"/>
-              </a:rPr>
-              <a:t>Deployment : portfolio-deploy</a:t>
-            </a:r>
-            <a:endParaRPr lang="en-US" sz="1250" dirty="0"/>
-          </a:p>
-        </p:txBody>
-      </p:sp>
-      <p:sp>
-        <p:nvSpPr>
-          <p:cNvPr id="9" name="Text 7"/>
-          <p:cNvSpPr/>
-          <p:nvPr/>
-        </p:nvSpPr>
-        <p:spPr>
-          <a:xfrm>
-            <a:off x="548640" y="1517904"/>
-            <a:ext cx="4663440" cy="274320"/>
-          </a:xfrm>
-          <a:prstGeom prst="rect">
-            <a:avLst/>
-          </a:prstGeom>
-          <a:noFill/>
-          <a:ln/>
-        </p:spPr>
-        <p:txBody>
-          <a:bodyPr wrap="square" lIns="0" tIns="0" rIns="0" bIns="0" rtlCol="0" anchor="ctr"/>
-          <a:lstStyle/>
-          <a:p>
-            <a:pPr marL="0" indent="0">
-              <a:buNone/>
-            </a:pPr>
-            <a:r>
-              <a:rPr lang="en-US" sz="1050" dirty="0">
-                <a:solidFill>
-                  <a:srgbClr val="64748B"/>
-                </a:solidFill>
-                <a:latin typeface="Calibri" pitchFamily="34" charset="0"/>
-                <a:ea typeface="Calibri" pitchFamily="34" charset="-122"/>
-                <a:cs typeface="Calibri" pitchFamily="34" charset="-120"/>
-              </a:rPr>
-              <a:t>Manifeste Kubernetes géré par Jenkins via kubectl apply</a:t>
-            </a:r>
-            <a:endParaRPr lang="en-US" sz="1050" dirty="0"/>
-          </a:p>
-        </p:txBody>
-      </p:sp>
-      <p:sp>
-        <p:nvSpPr>
-          <p:cNvPr id="10" name="Shape 8"/>
-          <p:cNvSpPr/>
-          <p:nvPr/>
-        </p:nvSpPr>
-        <p:spPr>
-          <a:xfrm>
-            <a:off x="320040" y="2084832"/>
-            <a:ext cx="5029200" cy="749808"/>
-          </a:xfrm>
-          <a:prstGeom prst="rect">
-            <a:avLst/>
-          </a:prstGeom>
-          <a:solidFill>
-            <a:srgbClr val="FFFFFF"/>
-          </a:solidFill>
-          <a:ln w="12700">
-            <a:solidFill>
-              <a:srgbClr val="BFDBFE"/>
-            </a:solidFill>
-            <a:prstDash val="solid"/>
-          </a:ln>
-          <a:effectLst>
-            <a:outerShdw blurRad="101600" dist="25400" dir="8100000" algn="bl" rotWithShape="0">
-              <a:srgbClr val="000000">
-                <a:alpha val="10000"/>
-              </a:srgbClr>
-            </a:outerShdw>
-          </a:effectLst>
-        </p:spPr>
-      </p:sp>
-      <p:sp>
-        <p:nvSpPr>
-          <p:cNvPr id="11" name="Shape 9"/>
-          <p:cNvSpPr/>
-          <p:nvPr/>
-        </p:nvSpPr>
-        <p:spPr>
-          <a:xfrm>
-            <a:off x="320040" y="2084832"/>
-            <a:ext cx="64008" cy="749808"/>
-          </a:xfrm>
-          <a:prstGeom prst="rect">
-            <a:avLst/>
-          </a:prstGeom>
-          <a:solidFill>
-            <a:srgbClr val="2196F3"/>
-          </a:solidFill>
-          <a:ln w="12700">
-            <a:solidFill>
-              <a:srgbClr val="2196F3"/>
-            </a:solidFill>
-            <a:prstDash val="solid"/>
-          </a:ln>
-        </p:spPr>
-      </p:sp>
-      <p:sp>
-        <p:nvSpPr>
-          <p:cNvPr id="12" name="Text 10"/>
-          <p:cNvSpPr/>
-          <p:nvPr/>
-        </p:nvSpPr>
-        <p:spPr>
-          <a:xfrm>
-            <a:off x="548640" y="2130552"/>
-            <a:ext cx="4663440" cy="274320"/>
-          </a:xfrm>
-          <a:prstGeom prst="rect">
-            <a:avLst/>
-          </a:prstGeom>
-          <a:noFill/>
-          <a:ln/>
-        </p:spPr>
-        <p:txBody>
-          <a:bodyPr wrap="square" lIns="0" tIns="0" rIns="0" bIns="0" rtlCol="0" anchor="ctr"/>
-          <a:lstStyle/>
-          <a:p>
-            <a:pPr marL="0" indent="0">
-              <a:buNone/>
-            </a:pPr>
-            <a:r>
-              <a:rPr lang="en-US" sz="1250" b="1" dirty="0">
-                <a:solidFill>
-                  <a:srgbClr val="1E293B"/>
-                </a:solidFill>
-                <a:latin typeface="Calibri" pitchFamily="34" charset="0"/>
-                <a:ea typeface="Calibri" pitchFamily="34" charset="-122"/>
-                <a:cs typeface="Calibri" pitchFamily="34" charset="-120"/>
-              </a:rPr>
-              <a:t>Pod : portfolio-container</a:t>
-            </a:r>
-            <a:endParaRPr lang="en-US" sz="1250" dirty="0"/>
-          </a:p>
-        </p:txBody>
-      </p:sp>
-      <p:sp>
-        <p:nvSpPr>
-          <p:cNvPr id="13" name="Text 11"/>
-          <p:cNvSpPr/>
-          <p:nvPr/>
-        </p:nvSpPr>
-        <p:spPr>
-          <a:xfrm>
-            <a:off x="548640" y="2414016"/>
-            <a:ext cx="4663440" cy="274320"/>
-          </a:xfrm>
-          <a:prstGeom prst="rect">
-            <a:avLst/>
-          </a:prstGeom>
-          <a:noFill/>
-          <a:ln/>
-        </p:spPr>
-        <p:txBody>
-          <a:bodyPr wrap="square" lIns="0" tIns="0" rIns="0" bIns="0" rtlCol="0" anchor="ctr"/>
-          <a:lstStyle/>
-          <a:p>
-            <a:pPr marL="0" indent="0">
-              <a:buNone/>
-            </a:pPr>
-            <a:r>
-              <a:rPr lang="en-US" sz="1050" dirty="0">
-                <a:solidFill>
-                  <a:srgbClr val="64748B"/>
-                </a:solidFill>
-                <a:latin typeface="Calibri" pitchFamily="34" charset="0"/>
-                <a:ea typeface="Calibri" pitchFamily="34" charset="-122"/>
-                <a:cs typeface="Calibri" pitchFamily="34" charset="-120"/>
-              </a:rPr>
-              <a:t>Image Docker versionnée depuis Docker Hub (:$BUILD_NUMBER)</a:t>
-            </a:r>
-            <a:endParaRPr lang="en-US" sz="1050" dirty="0"/>
-          </a:p>
-        </p:txBody>
-      </p:sp>
-      <p:sp>
-        <p:nvSpPr>
-          <p:cNvPr id="14" name="Shape 12"/>
-          <p:cNvSpPr/>
-          <p:nvPr/>
-        </p:nvSpPr>
-        <p:spPr>
-          <a:xfrm>
-            <a:off x="320040" y="2980944"/>
-            <a:ext cx="5029200" cy="749808"/>
-          </a:xfrm>
-          <a:prstGeom prst="rect">
-            <a:avLst/>
-          </a:prstGeom>
-          <a:solidFill>
-            <a:srgbClr val="FFFFFF"/>
-          </a:solidFill>
-          <a:ln w="12700">
-            <a:solidFill>
-              <a:srgbClr val="BFDBFE"/>
-            </a:solidFill>
-            <a:prstDash val="solid"/>
-          </a:ln>
-          <a:effectLst>
-            <a:outerShdw blurRad="101600" dist="25400" dir="8100000" algn="bl" rotWithShape="0">
-              <a:srgbClr val="000000">
-                <a:alpha val="10000"/>
-              </a:srgbClr>
-            </a:outerShdw>
-          </a:effectLst>
-        </p:spPr>
-      </p:sp>
-      <p:sp>
-        <p:nvSpPr>
-          <p:cNvPr id="15" name="Shape 13"/>
-          <p:cNvSpPr/>
-          <p:nvPr/>
-        </p:nvSpPr>
-        <p:spPr>
-          <a:xfrm>
-            <a:off x="320040" y="2980944"/>
-            <a:ext cx="64008" cy="749808"/>
-          </a:xfrm>
-          <a:prstGeom prst="rect">
-            <a:avLst/>
-          </a:prstGeom>
-          <a:solidFill>
-            <a:srgbClr val="00BCD4"/>
-          </a:solidFill>
-          <a:ln w="12700">
-            <a:solidFill>
-              <a:srgbClr val="00BCD4"/>
-            </a:solidFill>
-            <a:prstDash val="solid"/>
-          </a:ln>
-        </p:spPr>
-      </p:sp>
-      <p:sp>
-        <p:nvSpPr>
-          <p:cNvPr id="16" name="Text 14"/>
-          <p:cNvSpPr/>
-          <p:nvPr/>
-        </p:nvSpPr>
-        <p:spPr>
-          <a:xfrm>
-            <a:off x="548640" y="3026664"/>
-            <a:ext cx="4663440" cy="274320"/>
-          </a:xfrm>
-          <a:prstGeom prst="rect">
-            <a:avLst/>
-          </a:prstGeom>
-          <a:noFill/>
-          <a:ln/>
-        </p:spPr>
-        <p:txBody>
-          <a:bodyPr wrap="square" lIns="0" tIns="0" rIns="0" bIns="0" rtlCol="0" anchor="ctr"/>
-          <a:lstStyle/>
-          <a:p>
-            <a:pPr marL="0" indent="0">
-              <a:buNone/>
-            </a:pPr>
-            <a:r>
-              <a:rPr lang="en-US" sz="1250" b="1" dirty="0">
-                <a:solidFill>
-                  <a:srgbClr val="1E293B"/>
-                </a:solidFill>
-                <a:latin typeface="Calibri" pitchFamily="34" charset="0"/>
-                <a:ea typeface="Calibri" pitchFamily="34" charset="-122"/>
-                <a:cs typeface="Calibri" pitchFamily="34" charset="-120"/>
-              </a:rPr>
-              <a:t>Service : NodePort 30080</a:t>
-            </a:r>
-            <a:endParaRPr lang="en-US" sz="1250" dirty="0"/>
-          </a:p>
-        </p:txBody>
-      </p:sp>
-      <p:sp>
-        <p:nvSpPr>
-          <p:cNvPr id="17" name="Text 15"/>
-          <p:cNvSpPr/>
-          <p:nvPr/>
-        </p:nvSpPr>
-        <p:spPr>
-          <a:xfrm>
-            <a:off x="548640" y="3310128"/>
-            <a:ext cx="4663440" cy="274320"/>
-          </a:xfrm>
-          <a:prstGeom prst="rect">
-            <a:avLst/>
-          </a:prstGeom>
-          <a:noFill/>
-          <a:ln/>
-        </p:spPr>
-        <p:txBody>
-          <a:bodyPr wrap="square" lIns="0" tIns="0" rIns="0" bIns="0" rtlCol="0" anchor="ctr"/>
-          <a:lstStyle/>
-          <a:p>
-            <a:pPr marL="0" indent="0">
-              <a:buNone/>
-            </a:pPr>
-            <a:r>
-              <a:rPr lang="en-US" sz="1050" dirty="0">
-                <a:solidFill>
-                  <a:srgbClr val="64748B"/>
-                </a:solidFill>
-                <a:latin typeface="Calibri" pitchFamily="34" charset="0"/>
-                <a:ea typeface="Calibri" pitchFamily="34" charset="-122"/>
-                <a:cs typeface="Calibri" pitchFamily="34" charset="-120"/>
-              </a:rPr>
-              <a:t>Expose publiquement l'application sur worker-ip:30080</a:t>
-            </a:r>
-            <a:endParaRPr lang="en-US" sz="1050" dirty="0"/>
-          </a:p>
-        </p:txBody>
-      </p:sp>
-      <p:sp>
-        <p:nvSpPr>
-          <p:cNvPr id="18" name="Shape 16"/>
-          <p:cNvSpPr/>
-          <p:nvPr/>
-        </p:nvSpPr>
-        <p:spPr>
-          <a:xfrm>
-            <a:off x="320040" y="3877056"/>
-            <a:ext cx="5029200" cy="749808"/>
-          </a:xfrm>
-          <a:prstGeom prst="rect">
-            <a:avLst/>
-          </a:prstGeom>
-          <a:solidFill>
-            <a:srgbClr val="FFFFFF"/>
-          </a:solidFill>
-          <a:ln w="12700">
-            <a:solidFill>
-              <a:srgbClr val="BFDBFE"/>
-            </a:solidFill>
-            <a:prstDash val="solid"/>
-          </a:ln>
-          <a:effectLst>
-            <a:outerShdw blurRad="101600" dist="25400" dir="8100000" algn="bl" rotWithShape="0">
-              <a:srgbClr val="000000">
-                <a:alpha val="10000"/>
-              </a:srgbClr>
-            </a:outerShdw>
-          </a:effectLst>
-        </p:spPr>
-      </p:sp>
-      <p:sp>
-        <p:nvSpPr>
-          <p:cNvPr id="19" name="Shape 17"/>
-          <p:cNvSpPr/>
-          <p:nvPr/>
-        </p:nvSpPr>
-        <p:spPr>
-          <a:xfrm>
-            <a:off x="320040" y="3877056"/>
-            <a:ext cx="64008" cy="749808"/>
-          </a:xfrm>
-          <a:prstGeom prst="rect">
-            <a:avLst/>
-          </a:prstGeom>
-          <a:solidFill>
-            <a:srgbClr val="10B981"/>
-          </a:solidFill>
-          <a:ln w="12700">
-            <a:solidFill>
-              <a:srgbClr val="10B981"/>
-            </a:solidFill>
-            <a:prstDash val="solid"/>
-          </a:ln>
-        </p:spPr>
-      </p:sp>
-      <p:sp>
-        <p:nvSpPr>
-          <p:cNvPr id="20" name="Text 18"/>
-          <p:cNvSpPr/>
-          <p:nvPr/>
-        </p:nvSpPr>
-        <p:spPr>
-          <a:xfrm>
-            <a:off x="548640" y="3922776"/>
-            <a:ext cx="4663440" cy="274320"/>
-          </a:xfrm>
-          <a:prstGeom prst="rect">
-            <a:avLst/>
-          </a:prstGeom>
-          <a:noFill/>
-          <a:ln/>
-        </p:spPr>
-        <p:txBody>
-          <a:bodyPr wrap="square" lIns="0" tIns="0" rIns="0" bIns="0" rtlCol="0" anchor="ctr"/>
-          <a:lstStyle/>
-          <a:p>
-            <a:pPr marL="0" indent="0">
-              <a:buNone/>
-            </a:pPr>
-            <a:r>
-              <a:rPr lang="en-US" sz="1250" b="1" dirty="0">
-                <a:solidFill>
-                  <a:srgbClr val="1E293B"/>
-                </a:solidFill>
-                <a:latin typeface="Calibri" pitchFamily="34" charset="0"/>
-                <a:ea typeface="Calibri" pitchFamily="34" charset="-122"/>
-                <a:cs typeface="Calibri" pitchFamily="34" charset="-120"/>
-              </a:rPr>
-              <a:t>Ressources limitées</a:t>
-            </a:r>
-            <a:endParaRPr lang="en-US" sz="1250" dirty="0"/>
-          </a:p>
-        </p:txBody>
-      </p:sp>
-      <p:sp>
-        <p:nvSpPr>
-          <p:cNvPr id="21" name="Text 19"/>
-          <p:cNvSpPr/>
-          <p:nvPr/>
-        </p:nvSpPr>
-        <p:spPr>
-          <a:xfrm>
-            <a:off x="548640" y="4206240"/>
-            <a:ext cx="4663440" cy="274320"/>
-          </a:xfrm>
-          <a:prstGeom prst="rect">
-            <a:avLst/>
-          </a:prstGeom>
-          <a:noFill/>
-          <a:ln/>
-        </p:spPr>
-        <p:txBody>
-          <a:bodyPr wrap="square" lIns="0" tIns="0" rIns="0" bIns="0" rtlCol="0" anchor="ctr"/>
-          <a:lstStyle/>
-          <a:p>
-            <a:pPr marL="0" indent="0">
-              <a:buNone/>
-            </a:pPr>
-            <a:r>
-              <a:rPr lang="en-US" sz="1050" dirty="0">
-                <a:solidFill>
-                  <a:srgbClr val="64748B"/>
-                </a:solidFill>
-                <a:latin typeface="Calibri" pitchFamily="34" charset="0"/>
-                <a:ea typeface="Calibri" pitchFamily="34" charset="-122"/>
-                <a:cs typeface="Calibri" pitchFamily="34" charset="-120"/>
-              </a:rPr>
-              <a:t>256Mi RAM · 250m CPU par pod — optimisé pour t3.micro</a:t>
-            </a:r>
-            <a:endParaRPr lang="en-US" sz="1050" dirty="0"/>
-          </a:p>
-        </p:txBody>
-      </p:sp>
-      <p:sp>
-        <p:nvSpPr>
-          <p:cNvPr id="22" name="Shape 20"/>
-          <p:cNvSpPr/>
-          <p:nvPr/>
-        </p:nvSpPr>
-        <p:spPr>
-          <a:xfrm>
-            <a:off x="5623560" y="1097280"/>
-            <a:ext cx="3200400" cy="3749040"/>
-          </a:xfrm>
-          <a:prstGeom prst="rect">
-            <a:avLst/>
-          </a:prstGeom>
-          <a:solidFill>
-            <a:srgbClr val="EFF6FF"/>
-          </a:solidFill>
-          <a:ln w="12700">
-            <a:solidFill>
-              <a:srgbClr val="BFDBFE"/>
-            </a:solidFill>
-            <a:prstDash val="solid"/>
-          </a:ln>
-          <a:effectLst>
-            <a:outerShdw blurRad="101600" dist="25400" dir="8100000" algn="bl" rotWithShape="0">
-              <a:srgbClr val="000000">
-                <a:alpha val="10000"/>
-              </a:srgbClr>
-            </a:outerShdw>
-          </a:effectLst>
-        </p:spPr>
-      </p:sp>
-      <p:sp>
-        <p:nvSpPr>
-          <p:cNvPr id="23" name="Text 21"/>
-          <p:cNvSpPr/>
-          <p:nvPr/>
-        </p:nvSpPr>
-        <p:spPr>
-          <a:xfrm>
-            <a:off x="5760720" y="1170432"/>
-            <a:ext cx="2926080" cy="320040"/>
-          </a:xfrm>
-          <a:prstGeom prst="rect">
-            <a:avLst/>
-          </a:prstGeom>
-          <a:noFill/>
-          <a:ln/>
-        </p:spPr>
-        <p:txBody>
-          <a:bodyPr wrap="square" rtlCol="0" anchor="ctr"/>
-          <a:lstStyle/>
-          <a:p>
-            <a:pPr marL="0" indent="0" algn="ctr">
-              <a:buNone/>
-            </a:pPr>
-            <a:r>
-              <a:rPr lang="en-US" sz="1300" b="1" dirty="0">
-                <a:solidFill>
-                  <a:srgbClr val="0D1B2A"/>
-                </a:solidFill>
-                <a:latin typeface="Calibri" pitchFamily="34" charset="0"/>
-                <a:ea typeface="Calibri" pitchFamily="34" charset="-122"/>
-                <a:cs typeface="Calibri" pitchFamily="34" charset="-120"/>
-              </a:rPr>
-              <a:t>Architecture K3s</a:t>
-            </a:r>
-            <a:endParaRPr lang="en-US" sz="1300" dirty="0"/>
-          </a:p>
-        </p:txBody>
-      </p:sp>
-      <p:sp>
-        <p:nvSpPr>
-          <p:cNvPr id="24" name="Shape 22"/>
-          <p:cNvSpPr/>
-          <p:nvPr/>
-        </p:nvSpPr>
-        <p:spPr>
-          <a:xfrm>
-            <a:off x="5943600" y="1600200"/>
-            <a:ext cx="2743200" cy="685800"/>
-          </a:xfrm>
-          <a:prstGeom prst="rect">
-            <a:avLst/>
-          </a:prstGeom>
-          <a:solidFill>
-            <a:srgbClr val="326CE5"/>
-          </a:solidFill>
-          <a:ln w="12700">
-            <a:solidFill>
-              <a:srgbClr val="326CE5"/>
-            </a:solidFill>
-            <a:prstDash val="solid"/>
-          </a:ln>
-          <a:effectLst>
-            <a:outerShdw blurRad="101600" dist="25400" dir="8100000" algn="bl" rotWithShape="0">
-              <a:srgbClr val="000000">
-                <a:alpha val="10000"/>
-              </a:srgbClr>
-            </a:outerShdw>
-          </a:effectLst>
-        </p:spPr>
-      </p:sp>
-      <p:pic>
-        <p:nvPicPr>
-          <p:cNvPr id="25" name="Image 0"/>
-          <p:cNvPicPr>
-            <a:picLocks noChangeAspect="1"/>
-          </p:cNvPicPr>
-          <p:nvPr/>
-        </p:nvPicPr>
-        <p:blipFill>
-          <a:blip r:embed="rId3"/>
-          <a:srcRect/>
-          <a:stretch/>
-        </p:blipFill>
-        <p:spPr>
-          <a:xfrm>
-            <a:off x="5989320" y="1664208"/>
-            <a:ext cx="457200" cy="457200"/>
-          </a:xfrm>
-          <a:prstGeom prst="rect">
-            <a:avLst/>
-          </a:prstGeom>
-          <a:noFill/>
-        </p:spPr>
-      </p:pic>
-      <p:sp>
-        <p:nvSpPr>
-          <p:cNvPr id="26" name="Text 23"/>
-          <p:cNvSpPr/>
-          <p:nvPr/>
-        </p:nvSpPr>
-        <p:spPr>
-          <a:xfrm>
-            <a:off x="6492240" y="1645920"/>
-            <a:ext cx="2103120" cy="548640"/>
-          </a:xfrm>
-          <a:prstGeom prst="rect">
-            <a:avLst/>
-          </a:prstGeom>
-          <a:noFill/>
-          <a:ln/>
-        </p:spPr>
-        <p:txBody>
-          <a:bodyPr wrap="square" lIns="0" tIns="0" rIns="0" bIns="0" rtlCol="0" anchor="ctr"/>
-          <a:lstStyle/>
-          <a:p>
-            <a:pPr marL="0" indent="0">
-              <a:buNone/>
-            </a:pPr>
-            <a:r>
-              <a:rPr lang="en-US" sz="1000" dirty="0">
-                <a:solidFill>
-                  <a:srgbClr val="FFFFFF"/>
-                </a:solidFill>
-                <a:latin typeface="Calibri" pitchFamily="34" charset="0"/>
-                <a:ea typeface="Calibri" pitchFamily="34" charset="-122"/>
-                <a:cs typeface="Calibri" pitchFamily="34" charset="-120"/>
-              </a:rPr>
-              <a:t>K3s Master Node</a:t>
-            </a:r>
-            <a:endParaRPr lang="en-US" sz="1000" dirty="0"/>
-          </a:p>
-          <a:p>
-            <a:pPr marL="0" indent="0">
-              <a:buNone/>
-            </a:pPr>
-            <a:r>
-              <a:rPr lang="en-US" sz="1000" dirty="0">
-                <a:solidFill>
-                  <a:srgbClr val="FFFFFF"/>
-                </a:solidFill>
-                <a:latin typeface="Calibri" pitchFamily="34" charset="0"/>
-                <a:ea typeface="Calibri" pitchFamily="34" charset="-122"/>
-                <a:cs typeface="Calibri" pitchFamily="34" charset="-120"/>
-              </a:rPr>
-              <a:t>API Server · etcd · Scheduler</a:t>
-            </a:r>
-            <a:endParaRPr lang="en-US" sz="1000" dirty="0"/>
-          </a:p>
-        </p:txBody>
-      </p:sp>
-      <p:sp>
-        <p:nvSpPr>
-          <p:cNvPr id="27" name="Text 24"/>
-          <p:cNvSpPr/>
-          <p:nvPr/>
-        </p:nvSpPr>
-        <p:spPr>
-          <a:xfrm>
-            <a:off x="6858000" y="2359152"/>
-            <a:ext cx="457200" cy="274320"/>
-          </a:xfrm>
-          <a:prstGeom prst="rect">
-            <a:avLst/>
-          </a:prstGeom>
-          <a:noFill/>
-          <a:ln/>
-        </p:spPr>
-        <p:txBody>
-          <a:bodyPr wrap="square" rtlCol="0" anchor="ctr"/>
-          <a:lstStyle/>
-          <a:p>
-            <a:pPr marL="0" indent="0" algn="ctr">
-              <a:buNone/>
-            </a:pPr>
-            <a:r>
-              <a:rPr lang="en-US" sz="1800" dirty="0">
-                <a:solidFill>
-                  <a:srgbClr val="2196F3"/>
-                </a:solidFill>
-                <a:latin typeface="Calibri" pitchFamily="34" charset="0"/>
-                <a:ea typeface="Calibri" pitchFamily="34" charset="-122"/>
-                <a:cs typeface="Calibri" pitchFamily="34" charset="-120"/>
-              </a:rPr>
-              <a:t>↓</a:t>
-            </a:r>
-            <a:endParaRPr lang="en-US" sz="1800" dirty="0"/>
-          </a:p>
-        </p:txBody>
-      </p:sp>
-      <p:sp>
-        <p:nvSpPr>
-          <p:cNvPr id="28" name="Shape 25"/>
-          <p:cNvSpPr/>
-          <p:nvPr/>
-        </p:nvSpPr>
-        <p:spPr>
-          <a:xfrm>
-            <a:off x="5943600" y="2697480"/>
-            <a:ext cx="2743200" cy="685800"/>
-          </a:xfrm>
-          <a:prstGeom prst="rect">
-            <a:avLst/>
-          </a:prstGeom>
-          <a:solidFill>
-            <a:srgbClr val="2196F3"/>
-          </a:solidFill>
-          <a:ln w="12700">
-            <a:solidFill>
-              <a:srgbClr val="2196F3"/>
-            </a:solidFill>
-            <a:prstDash val="solid"/>
-          </a:ln>
-          <a:effectLst>
-            <a:outerShdw blurRad="101600" dist="25400" dir="8100000" algn="bl" rotWithShape="0">
-              <a:srgbClr val="000000">
-                <a:alpha val="10000"/>
-              </a:srgbClr>
-            </a:outerShdw>
-          </a:effectLst>
-        </p:spPr>
-      </p:sp>
-      <p:pic>
-        <p:nvPicPr>
-          <p:cNvPr id="29" name="Image 1" descr="preencoded.png"/>
-          <p:cNvPicPr>
-            <a:picLocks noChangeAspect="1"/>
-          </p:cNvPicPr>
-          <p:nvPr/>
-        </p:nvPicPr>
-        <p:blipFill>
-          <a:blip r:embed="rId4"/>
-          <a:stretch>
-            <a:fillRect/>
-          </a:stretch>
-        </p:blipFill>
-        <p:spPr>
-          <a:xfrm>
-            <a:off x="5989320" y="2761488"/>
-            <a:ext cx="457200" cy="457200"/>
-          </a:xfrm>
-          <a:prstGeom prst="rect">
-            <a:avLst/>
-          </a:prstGeom>
-        </p:spPr>
-      </p:pic>
-      <p:sp>
-        <p:nvSpPr>
-          <p:cNvPr id="30" name="Text 26"/>
-          <p:cNvSpPr/>
-          <p:nvPr/>
-        </p:nvSpPr>
-        <p:spPr>
-          <a:xfrm>
-            <a:off x="6492240" y="2743200"/>
-            <a:ext cx="2103120" cy="548640"/>
-          </a:xfrm>
-          <a:prstGeom prst="rect">
-            <a:avLst/>
-          </a:prstGeom>
-          <a:noFill/>
-          <a:ln/>
-        </p:spPr>
-        <p:txBody>
-          <a:bodyPr wrap="square" lIns="0" tIns="0" rIns="0" bIns="0" rtlCol="0" anchor="ctr"/>
-          <a:lstStyle/>
-          <a:p>
-            <a:pPr marL="0" indent="0">
-              <a:buNone/>
-            </a:pPr>
-            <a:r>
-              <a:rPr lang="en-US" sz="1000" dirty="0">
-                <a:solidFill>
-                  <a:srgbClr val="FFFFFF"/>
-                </a:solidFill>
-                <a:latin typeface="Calibri" pitchFamily="34" charset="0"/>
-                <a:ea typeface="Calibri" pitchFamily="34" charset="-122"/>
-                <a:cs typeface="Calibri" pitchFamily="34" charset="-120"/>
-              </a:rPr>
-              <a:t>K3s Worker Node</a:t>
-            </a:r>
-            <a:endParaRPr lang="en-US" sz="1000" dirty="0"/>
-          </a:p>
-          <a:p>
-            <a:pPr marL="0" indent="0">
-              <a:buNone/>
-            </a:pPr>
-            <a:r>
-              <a:rPr lang="en-US" sz="1000" dirty="0">
-                <a:solidFill>
-                  <a:srgbClr val="FFFFFF"/>
-                </a:solidFill>
-                <a:latin typeface="Calibri" pitchFamily="34" charset="0"/>
-                <a:ea typeface="Calibri" pitchFamily="34" charset="-122"/>
-                <a:cs typeface="Calibri" pitchFamily="34" charset="-120"/>
-              </a:rPr>
-              <a:t>Container Runtime · kubelet</a:t>
-            </a:r>
-            <a:endParaRPr lang="en-US" sz="1000" dirty="0"/>
-          </a:p>
-        </p:txBody>
-      </p:sp>
-      <p:sp>
-        <p:nvSpPr>
-          <p:cNvPr id="31" name="Shape 27"/>
-          <p:cNvSpPr/>
-          <p:nvPr/>
-        </p:nvSpPr>
-        <p:spPr>
-          <a:xfrm>
-            <a:off x="6035040" y="3520440"/>
-            <a:ext cx="2560320" cy="548640"/>
-          </a:xfrm>
-          <a:prstGeom prst="rect">
-            <a:avLst/>
-          </a:prstGeom>
-          <a:solidFill>
-            <a:srgbClr val="E3F2FD"/>
-          </a:solidFill>
-          <a:ln w="12700">
-            <a:solidFill>
-              <a:srgbClr val="2196F3"/>
-            </a:solidFill>
-            <a:prstDash val="solid"/>
-          </a:ln>
-        </p:spPr>
-      </p:sp>
-      <p:pic>
-        <p:nvPicPr>
-          <p:cNvPr id="32" name="Image 2" descr="preencoded.png"/>
-          <p:cNvPicPr>
-            <a:picLocks noChangeAspect="1"/>
-          </p:cNvPicPr>
-          <p:nvPr/>
-        </p:nvPicPr>
-        <p:blipFill>
-          <a:blip r:embed="rId5"/>
-          <a:stretch>
-            <a:fillRect/>
-          </a:stretch>
-        </p:blipFill>
-        <p:spPr>
-          <a:xfrm>
-            <a:off x="6080760" y="3584448"/>
-            <a:ext cx="365760" cy="365760"/>
-          </a:xfrm>
-          <a:prstGeom prst="rect">
-            <a:avLst/>
-          </a:prstGeom>
-        </p:spPr>
-      </p:pic>
-      <p:sp>
-        <p:nvSpPr>
-          <p:cNvPr id="33" name="Text 28"/>
-          <p:cNvSpPr/>
-          <p:nvPr/>
-        </p:nvSpPr>
-        <p:spPr>
-          <a:xfrm>
-            <a:off x="6492240" y="3566160"/>
-            <a:ext cx="2011680" cy="438912"/>
-          </a:xfrm>
-          <a:prstGeom prst="rect">
-            <a:avLst/>
-          </a:prstGeom>
-          <a:noFill/>
-          <a:ln/>
-        </p:spPr>
-        <p:txBody>
-          <a:bodyPr wrap="square" lIns="0" tIns="0" rIns="0" bIns="0" rtlCol="0" anchor="ctr"/>
-          <a:lstStyle/>
-          <a:p>
-            <a:pPr marL="0" indent="0">
-              <a:buNone/>
-            </a:pPr>
-            <a:r>
-              <a:rPr lang="en-US" sz="1000" dirty="0">
-                <a:solidFill>
-                  <a:srgbClr val="1B3A6B"/>
-                </a:solidFill>
-                <a:latin typeface="Calibri" pitchFamily="34" charset="0"/>
-                <a:ea typeface="Calibri" pitchFamily="34" charset="-122"/>
-                <a:cs typeface="Calibri" pitchFamily="34" charset="-120"/>
-              </a:rPr>
-              <a:t>Pod: portfolio-container</a:t>
-            </a:r>
-            <a:endParaRPr lang="en-US" sz="1000" dirty="0"/>
-          </a:p>
-          <a:p>
-            <a:pPr marL="0" indent="0">
-              <a:buNone/>
-            </a:pPr>
-            <a:r>
-              <a:rPr lang="en-US" sz="1000" dirty="0">
-                <a:solidFill>
-                  <a:srgbClr val="1B3A6B"/>
-                </a:solidFill>
-                <a:latin typeface="Calibri" pitchFamily="34" charset="0"/>
-                <a:ea typeface="Calibri" pitchFamily="34" charset="-122"/>
-                <a:cs typeface="Calibri" pitchFamily="34" charset="-120"/>
-              </a:rPr>
-              <a:t>:30080</a:t>
-            </a:r>
-            <a:endParaRPr lang="en-US" sz="1000" dirty="0"/>
-          </a:p>
-        </p:txBody>
-      </p:sp>
-    </p:spTree>
-  </p:cSld>
-  <p:clrMapOvr>
-    <a:masterClrMapping/>
-  </p:clrMapOvr>
-</p:sld>
-</file>
-
-<file path=ppt/slides/slide11.xml><?xml version="1.0" encoding="utf-8"?>
-<p:sld xmlns:a="http://schemas.openxmlformats.org/drawingml/2006/main" xmlns:r="http://schemas.openxmlformats.org/officeDocument/2006/relationships" xmlns:p="http://schemas.openxmlformats.org/presentationml/2006/main">
   <p:cSld name="Slide 11">
     <p:bg>
       <p:bgPr>
@@ -4664,7 +3439,7 @@
 </p:sld>
 </file>
 
-<file path=ppt/slides/slide12.xml><?xml version="1.0" encoding="utf-8"?>
+<file path=ppt/slides/slide11.xml><?xml version="1.0" encoding="utf-8"?>
 <p:sld xmlns:a="http://schemas.openxmlformats.org/drawingml/2006/main" xmlns:r="http://schemas.openxmlformats.org/officeDocument/2006/relationships" xmlns:p="http://schemas.openxmlformats.org/presentationml/2006/main">
   <p:cSld name="Slide 12">
     <p:bg>
@@ -5753,7 +4528,7 @@
 </p:sld>
 </file>
 
-<file path=ppt/slides/slide13.xml><?xml version="1.0" encoding="utf-8"?>
+<file path=ppt/slides/slide12.xml><?xml version="1.0" encoding="utf-8"?>
 <p:sld xmlns:a="http://schemas.openxmlformats.org/drawingml/2006/main" xmlns:r="http://schemas.openxmlformats.org/officeDocument/2006/relationships" xmlns:p="http://schemas.openxmlformats.org/presentationml/2006/main">
   <p:cSld name="Slide 13">
     <p:bg>
@@ -6980,7 +5755,7 @@
 </p:sld>
 </file>
 
-<file path=ppt/slides/slide14.xml><?xml version="1.0" encoding="utf-8"?>
+<file path=ppt/slides/slide13.xml><?xml version="1.0" encoding="utf-8"?>
 <p:sld xmlns:a="http://schemas.openxmlformats.org/drawingml/2006/main" xmlns:r="http://schemas.openxmlformats.org/officeDocument/2006/relationships" xmlns:p="http://schemas.openxmlformats.org/presentationml/2006/main">
   <p:cSld name="Slide 14">
     <p:bg>
@@ -10308,2151 +9083,6 @@
 
 <file path=ppt/slides/slide4.xml><?xml version="1.0" encoding="utf-8"?>
 <p:sld xmlns:a="http://schemas.openxmlformats.org/drawingml/2006/main" xmlns:r="http://schemas.openxmlformats.org/officeDocument/2006/relationships" xmlns:p="http://schemas.openxmlformats.org/presentationml/2006/main">
-  <p:cSld name="Slide 4">
-    <p:bg>
-      <p:bgPr>
-        <a:solidFill>
-          <a:srgbClr val="F4F8FC"/>
-        </a:solidFill>
-        <a:effectLst/>
-      </p:bgPr>
-    </p:bg>
-    <p:spTree>
-      <p:nvGrpSpPr>
-        <p:cNvPr id="1" name=""/>
-        <p:cNvGrpSpPr/>
-        <p:nvPr/>
-      </p:nvGrpSpPr>
-      <p:grpSpPr>
-        <a:xfrm>
-          <a:off x="0" y="0"/>
-          <a:ext cx="0" cy="0"/>
-          <a:chOff x="0" y="0"/>
-          <a:chExt cx="0" cy="0"/>
-        </a:xfrm>
-      </p:grpSpPr>
-      <p:sp>
-        <p:nvSpPr>
-          <p:cNvPr id="2" name="Shape 0"/>
-          <p:cNvSpPr/>
-          <p:nvPr/>
-        </p:nvSpPr>
-        <p:spPr>
-          <a:xfrm>
-            <a:off x="0" y="0"/>
-            <a:ext cx="9144000" cy="1005840"/>
-          </a:xfrm>
-          <a:prstGeom prst="rect">
-            <a:avLst/>
-          </a:prstGeom>
-          <a:solidFill>
-            <a:srgbClr val="0D1B2A"/>
-          </a:solidFill>
-          <a:ln w="12700">
-            <a:solidFill>
-              <a:srgbClr val="0D1B2A"/>
-            </a:solidFill>
-            <a:prstDash val="solid"/>
-          </a:ln>
-        </p:spPr>
-      </p:sp>
-      <p:sp>
-        <p:nvSpPr>
-          <p:cNvPr id="3" name="Shape 1"/>
-          <p:cNvSpPr/>
-          <p:nvPr/>
-        </p:nvSpPr>
-        <p:spPr>
-          <a:xfrm>
-            <a:off x="0" y="960120"/>
-            <a:ext cx="9144000" cy="45720"/>
-          </a:xfrm>
-          <a:prstGeom prst="rect">
-            <a:avLst/>
-          </a:prstGeom>
-          <a:solidFill>
-            <a:srgbClr val="2196F3"/>
-          </a:solidFill>
-          <a:ln w="12700">
-            <a:solidFill>
-              <a:srgbClr val="2196F3"/>
-            </a:solidFill>
-            <a:prstDash val="solid"/>
-          </a:ln>
-        </p:spPr>
-      </p:sp>
-      <p:sp>
-        <p:nvSpPr>
-          <p:cNvPr id="4" name="Text 2"/>
-          <p:cNvSpPr/>
-          <p:nvPr/>
-        </p:nvSpPr>
-        <p:spPr>
-          <a:xfrm>
-            <a:off x="411480" y="109728"/>
-            <a:ext cx="7315200" cy="548640"/>
-          </a:xfrm>
-          <a:prstGeom prst="rect">
-            <a:avLst/>
-          </a:prstGeom>
-          <a:noFill/>
-          <a:ln/>
-        </p:spPr>
-        <p:txBody>
-          <a:bodyPr wrap="square" lIns="0" tIns="0" rIns="0" bIns="0" rtlCol="0" anchor="ctr"/>
-          <a:lstStyle/>
-          <a:p>
-            <a:pPr marL="0" indent="0">
-              <a:buNone/>
-            </a:pPr>
-            <a:r>
-              <a:rPr lang="en-US" sz="2600" b="1" dirty="0">
-                <a:solidFill>
-                  <a:srgbClr val="FFFFFF"/>
-                </a:solidFill>
-                <a:latin typeface="Calibri" pitchFamily="34" charset="0"/>
-                <a:ea typeface="Calibri" pitchFamily="34" charset="-122"/>
-                <a:cs typeface="Calibri" pitchFamily="34" charset="-120"/>
-              </a:rPr>
-              <a:t>Pipeline Global du Projet</a:t>
-            </a:r>
-            <a:endParaRPr lang="en-US" sz="2600" dirty="0"/>
-          </a:p>
-        </p:txBody>
-      </p:sp>
-      <p:sp>
-        <p:nvSpPr>
-          <p:cNvPr id="5" name="Text 3"/>
-          <p:cNvSpPr/>
-          <p:nvPr/>
-        </p:nvSpPr>
-        <p:spPr>
-          <a:xfrm>
-            <a:off x="411480" y="594360"/>
-            <a:ext cx="7315200" cy="347472"/>
-          </a:xfrm>
-          <a:prstGeom prst="rect">
-            <a:avLst/>
-          </a:prstGeom>
-          <a:noFill/>
-          <a:ln/>
-        </p:spPr>
-        <p:txBody>
-          <a:bodyPr wrap="square" lIns="0" tIns="0" rIns="0" bIns="0" rtlCol="0" anchor="ctr"/>
-          <a:lstStyle/>
-          <a:p>
-            <a:pPr marL="0" indent="0">
-              <a:buNone/>
-            </a:pPr>
-            <a:r>
-              <a:rPr lang="en-US" sz="1300" i="1" dirty="0">
-                <a:solidFill>
-                  <a:srgbClr val="90CAF9"/>
-                </a:solidFill>
-                <a:latin typeface="Calibri" pitchFamily="34" charset="0"/>
-                <a:ea typeface="Calibri" pitchFamily="34" charset="-122"/>
-                <a:cs typeface="Calibri" pitchFamily="34" charset="-120"/>
-              </a:rPr>
-              <a:t>Flux bout en bout de l'infrastructure jusqu'au déploiement</a:t>
-            </a:r>
-            <a:endParaRPr lang="en-US" sz="1300" dirty="0"/>
-          </a:p>
-        </p:txBody>
-      </p:sp>
-      <p:sp>
-        <p:nvSpPr>
-          <p:cNvPr id="6" name="Shape 4"/>
-          <p:cNvSpPr/>
-          <p:nvPr/>
-        </p:nvSpPr>
-        <p:spPr>
-          <a:xfrm>
-            <a:off x="274320" y="1097280"/>
-            <a:ext cx="1920240" cy="365760"/>
-          </a:xfrm>
-          <a:prstGeom prst="rect">
-            <a:avLst/>
-          </a:prstGeom>
-          <a:solidFill>
-            <a:srgbClr val="7B42BC"/>
-          </a:solidFill>
-          <a:ln w="12700">
-            <a:solidFill>
-              <a:srgbClr val="7B42BC"/>
-            </a:solidFill>
-            <a:prstDash val="solid"/>
-          </a:ln>
-        </p:spPr>
-      </p:sp>
-      <p:sp>
-        <p:nvSpPr>
-          <p:cNvPr id="7" name="Text 5"/>
-          <p:cNvSpPr/>
-          <p:nvPr/>
-        </p:nvSpPr>
-        <p:spPr>
-          <a:xfrm>
-            <a:off x="274320" y="1097280"/>
-            <a:ext cx="1920240" cy="365760"/>
-          </a:xfrm>
-          <a:prstGeom prst="rect">
-            <a:avLst/>
-          </a:prstGeom>
-          <a:noFill/>
-          <a:ln/>
-        </p:spPr>
-        <p:txBody>
-          <a:bodyPr wrap="square" rtlCol="0" anchor="ctr"/>
-          <a:lstStyle/>
-          <a:p>
-            <a:pPr marL="0" indent="0" algn="ctr">
-              <a:buNone/>
-            </a:pPr>
-            <a:r>
-              <a:rPr lang="en-US" sz="1000" b="1" dirty="0">
-                <a:solidFill>
-                  <a:srgbClr val="FFFFFF"/>
-                </a:solidFill>
-                <a:latin typeface="Calibri" pitchFamily="34" charset="0"/>
-                <a:ea typeface="Calibri" pitchFamily="34" charset="-122"/>
-                <a:cs typeface="Calibri" pitchFamily="34" charset="-120"/>
-              </a:rPr>
-              <a:t>TERRAFORM</a:t>
-            </a:r>
-            <a:endParaRPr lang="en-US" sz="1000" dirty="0"/>
-          </a:p>
-        </p:txBody>
-      </p:sp>
-      <p:sp>
-        <p:nvSpPr>
-          <p:cNvPr id="8" name="Shape 6"/>
-          <p:cNvSpPr/>
-          <p:nvPr/>
-        </p:nvSpPr>
-        <p:spPr>
-          <a:xfrm>
-            <a:off x="274320" y="1600200"/>
-            <a:ext cx="1920240" cy="594360"/>
-          </a:xfrm>
-          <a:prstGeom prst="rect">
-            <a:avLst/>
-          </a:prstGeom>
-          <a:solidFill>
-            <a:srgbClr val="FFFFFF"/>
-          </a:solidFill>
-          <a:ln w="12700">
-            <a:solidFill>
-              <a:srgbClr val="BFDBFE"/>
-            </a:solidFill>
-            <a:prstDash val="solid"/>
-          </a:ln>
-          <a:effectLst>
-            <a:outerShdw blurRad="101600" dist="25400" dir="8100000" algn="bl" rotWithShape="0">
-              <a:srgbClr val="000000">
-                <a:alpha val="10000"/>
-              </a:srgbClr>
-            </a:outerShdw>
-          </a:effectLst>
-        </p:spPr>
-      </p:sp>
-      <p:sp>
-        <p:nvSpPr>
-          <p:cNvPr id="9" name="Shape 7"/>
-          <p:cNvSpPr/>
-          <p:nvPr/>
-        </p:nvSpPr>
-        <p:spPr>
-          <a:xfrm>
-            <a:off x="274320" y="1600200"/>
-            <a:ext cx="64008" cy="594360"/>
-          </a:xfrm>
-          <a:prstGeom prst="rect">
-            <a:avLst/>
-          </a:prstGeom>
-          <a:solidFill>
-            <a:srgbClr val="7B42BC"/>
-          </a:solidFill>
-          <a:ln w="12700">
-            <a:solidFill>
-              <a:srgbClr val="7B42BC"/>
-            </a:solidFill>
-            <a:prstDash val="solid"/>
-          </a:ln>
-        </p:spPr>
-      </p:sp>
-      <p:sp>
-        <p:nvSpPr>
-          <p:cNvPr id="10" name="Text 8"/>
-          <p:cNvSpPr/>
-          <p:nvPr/>
-        </p:nvSpPr>
-        <p:spPr>
-          <a:xfrm>
-            <a:off x="457200" y="1719072"/>
-            <a:ext cx="1645920" cy="347472"/>
-          </a:xfrm>
-          <a:prstGeom prst="rect">
-            <a:avLst/>
-          </a:prstGeom>
-          <a:noFill/>
-          <a:ln/>
-        </p:spPr>
-        <p:txBody>
-          <a:bodyPr wrap="square" lIns="0" tIns="0" rIns="0" bIns="0" rtlCol="0" anchor="ctr"/>
-          <a:lstStyle/>
-          <a:p>
-            <a:pPr marL="0" indent="0">
-              <a:buNone/>
-            </a:pPr>
-            <a:r>
-              <a:rPr lang="en-US" sz="1150" dirty="0">
-                <a:solidFill>
-                  <a:srgbClr val="1E293B"/>
-                </a:solidFill>
-                <a:latin typeface="Calibri" pitchFamily="34" charset="0"/>
-                <a:ea typeface="Calibri" pitchFamily="34" charset="-122"/>
-                <a:cs typeface="Calibri" pitchFamily="34" charset="-120"/>
-              </a:rPr>
-              <a:t>tf init</a:t>
-            </a:r>
-            <a:endParaRPr lang="en-US" sz="1150" dirty="0"/>
-          </a:p>
-        </p:txBody>
-      </p:sp>
-      <p:sp>
-        <p:nvSpPr>
-          <p:cNvPr id="11" name="Shape 9"/>
-          <p:cNvSpPr/>
-          <p:nvPr/>
-        </p:nvSpPr>
-        <p:spPr>
-          <a:xfrm>
-            <a:off x="274320" y="2313432"/>
-            <a:ext cx="1920240" cy="594360"/>
-          </a:xfrm>
-          <a:prstGeom prst="rect">
-            <a:avLst/>
-          </a:prstGeom>
-          <a:solidFill>
-            <a:srgbClr val="FFFFFF"/>
-          </a:solidFill>
-          <a:ln w="12700">
-            <a:solidFill>
-              <a:srgbClr val="BFDBFE"/>
-            </a:solidFill>
-            <a:prstDash val="solid"/>
-          </a:ln>
-          <a:effectLst>
-            <a:outerShdw blurRad="101600" dist="25400" dir="8100000" algn="bl" rotWithShape="0">
-              <a:srgbClr val="000000">
-                <a:alpha val="10000"/>
-              </a:srgbClr>
-            </a:outerShdw>
-          </a:effectLst>
-        </p:spPr>
-      </p:sp>
-      <p:sp>
-        <p:nvSpPr>
-          <p:cNvPr id="12" name="Shape 10"/>
-          <p:cNvSpPr/>
-          <p:nvPr/>
-        </p:nvSpPr>
-        <p:spPr>
-          <a:xfrm>
-            <a:off x="274320" y="2313432"/>
-            <a:ext cx="64008" cy="594360"/>
-          </a:xfrm>
-          <a:prstGeom prst="rect">
-            <a:avLst/>
-          </a:prstGeom>
-          <a:solidFill>
-            <a:srgbClr val="7B42BC"/>
-          </a:solidFill>
-          <a:ln w="12700">
-            <a:solidFill>
-              <a:srgbClr val="7B42BC"/>
-            </a:solidFill>
-            <a:prstDash val="solid"/>
-          </a:ln>
-        </p:spPr>
-      </p:sp>
-      <p:sp>
-        <p:nvSpPr>
-          <p:cNvPr id="13" name="Text 11"/>
-          <p:cNvSpPr/>
-          <p:nvPr/>
-        </p:nvSpPr>
-        <p:spPr>
-          <a:xfrm>
-            <a:off x="457200" y="2432304"/>
-            <a:ext cx="1645920" cy="347472"/>
-          </a:xfrm>
-          <a:prstGeom prst="rect">
-            <a:avLst/>
-          </a:prstGeom>
-          <a:noFill/>
-          <a:ln/>
-        </p:spPr>
-        <p:txBody>
-          <a:bodyPr wrap="square" lIns="0" tIns="0" rIns="0" bIns="0" rtlCol="0" anchor="ctr"/>
-          <a:lstStyle/>
-          <a:p>
-            <a:pPr marL="0" indent="0">
-              <a:buNone/>
-            </a:pPr>
-            <a:r>
-              <a:rPr lang="en-US" sz="1150" dirty="0">
-                <a:solidFill>
-                  <a:srgbClr val="1E293B"/>
-                </a:solidFill>
-                <a:latin typeface="Calibri" pitchFamily="34" charset="0"/>
-                <a:ea typeface="Calibri" pitchFamily="34" charset="-122"/>
-                <a:cs typeface="Calibri" pitchFamily="34" charset="-120"/>
-              </a:rPr>
-              <a:t>tf plan</a:t>
-            </a:r>
-            <a:endParaRPr lang="en-US" sz="1150" dirty="0"/>
-          </a:p>
-        </p:txBody>
-      </p:sp>
-      <p:sp>
-        <p:nvSpPr>
-          <p:cNvPr id="14" name="Shape 12"/>
-          <p:cNvSpPr/>
-          <p:nvPr/>
-        </p:nvSpPr>
-        <p:spPr>
-          <a:xfrm>
-            <a:off x="274320" y="3026664"/>
-            <a:ext cx="1920240" cy="594360"/>
-          </a:xfrm>
-          <a:prstGeom prst="rect">
-            <a:avLst/>
-          </a:prstGeom>
-          <a:solidFill>
-            <a:srgbClr val="FFFFFF"/>
-          </a:solidFill>
-          <a:ln w="12700">
-            <a:solidFill>
-              <a:srgbClr val="BFDBFE"/>
-            </a:solidFill>
-            <a:prstDash val="solid"/>
-          </a:ln>
-          <a:effectLst>
-            <a:outerShdw blurRad="101600" dist="25400" dir="8100000" algn="bl" rotWithShape="0">
-              <a:srgbClr val="000000">
-                <a:alpha val="10000"/>
-              </a:srgbClr>
-            </a:outerShdw>
-          </a:effectLst>
-        </p:spPr>
-      </p:sp>
-      <p:sp>
-        <p:nvSpPr>
-          <p:cNvPr id="15" name="Shape 13"/>
-          <p:cNvSpPr/>
-          <p:nvPr/>
-        </p:nvSpPr>
-        <p:spPr>
-          <a:xfrm>
-            <a:off x="274320" y="3026664"/>
-            <a:ext cx="64008" cy="594360"/>
-          </a:xfrm>
-          <a:prstGeom prst="rect">
-            <a:avLst/>
-          </a:prstGeom>
-          <a:solidFill>
-            <a:srgbClr val="7B42BC"/>
-          </a:solidFill>
-          <a:ln w="12700">
-            <a:solidFill>
-              <a:srgbClr val="7B42BC"/>
-            </a:solidFill>
-            <a:prstDash val="solid"/>
-          </a:ln>
-        </p:spPr>
-      </p:sp>
-      <p:sp>
-        <p:nvSpPr>
-          <p:cNvPr id="16" name="Text 14"/>
-          <p:cNvSpPr/>
-          <p:nvPr/>
-        </p:nvSpPr>
-        <p:spPr>
-          <a:xfrm>
-            <a:off x="457200" y="3145536"/>
-            <a:ext cx="1645920" cy="347472"/>
-          </a:xfrm>
-          <a:prstGeom prst="rect">
-            <a:avLst/>
-          </a:prstGeom>
-          <a:noFill/>
-          <a:ln/>
-        </p:spPr>
-        <p:txBody>
-          <a:bodyPr wrap="square" lIns="0" tIns="0" rIns="0" bIns="0" rtlCol="0" anchor="ctr"/>
-          <a:lstStyle/>
-          <a:p>
-            <a:pPr marL="0" indent="0">
-              <a:buNone/>
-            </a:pPr>
-            <a:r>
-              <a:rPr lang="en-US" sz="1150" dirty="0">
-                <a:solidFill>
-                  <a:srgbClr val="1E293B"/>
-                </a:solidFill>
-                <a:latin typeface="Calibri" pitchFamily="34" charset="0"/>
-                <a:ea typeface="Calibri" pitchFamily="34" charset="-122"/>
-                <a:cs typeface="Calibri" pitchFamily="34" charset="-120"/>
-              </a:rPr>
-              <a:t>tf apply</a:t>
-            </a:r>
-            <a:endParaRPr lang="en-US" sz="1150" dirty="0"/>
-          </a:p>
-        </p:txBody>
-      </p:sp>
-      <p:sp>
-        <p:nvSpPr>
-          <p:cNvPr id="17" name="Shape 15"/>
-          <p:cNvSpPr/>
-          <p:nvPr/>
-        </p:nvSpPr>
-        <p:spPr>
-          <a:xfrm>
-            <a:off x="274320" y="3739896"/>
-            <a:ext cx="1920240" cy="594360"/>
-          </a:xfrm>
-          <a:prstGeom prst="rect">
-            <a:avLst/>
-          </a:prstGeom>
-          <a:solidFill>
-            <a:srgbClr val="FFFFFF"/>
-          </a:solidFill>
-          <a:ln w="12700">
-            <a:solidFill>
-              <a:srgbClr val="BFDBFE"/>
-            </a:solidFill>
-            <a:prstDash val="solid"/>
-          </a:ln>
-          <a:effectLst>
-            <a:outerShdw blurRad="101600" dist="25400" dir="8100000" algn="bl" rotWithShape="0">
-              <a:srgbClr val="000000">
-                <a:alpha val="10000"/>
-              </a:srgbClr>
-            </a:outerShdw>
-          </a:effectLst>
-        </p:spPr>
-      </p:sp>
-      <p:sp>
-        <p:nvSpPr>
-          <p:cNvPr id="18" name="Shape 16"/>
-          <p:cNvSpPr/>
-          <p:nvPr/>
-        </p:nvSpPr>
-        <p:spPr>
-          <a:xfrm>
-            <a:off x="274320" y="3739896"/>
-            <a:ext cx="64008" cy="594360"/>
-          </a:xfrm>
-          <a:prstGeom prst="rect">
-            <a:avLst/>
-          </a:prstGeom>
-          <a:solidFill>
-            <a:srgbClr val="7B42BC"/>
-          </a:solidFill>
-          <a:ln w="12700">
-            <a:solidFill>
-              <a:srgbClr val="7B42BC"/>
-            </a:solidFill>
-            <a:prstDash val="solid"/>
-          </a:ln>
-        </p:spPr>
-      </p:sp>
-      <p:sp>
-        <p:nvSpPr>
-          <p:cNvPr id="19" name="Text 17"/>
-          <p:cNvSpPr/>
-          <p:nvPr/>
-        </p:nvSpPr>
-        <p:spPr>
-          <a:xfrm>
-            <a:off x="457200" y="3858768"/>
-            <a:ext cx="1645920" cy="347472"/>
-          </a:xfrm>
-          <a:prstGeom prst="rect">
-            <a:avLst/>
-          </a:prstGeom>
-          <a:noFill/>
-          <a:ln/>
-        </p:spPr>
-        <p:txBody>
-          <a:bodyPr wrap="square" lIns="0" tIns="0" rIns="0" bIns="0" rtlCol="0" anchor="ctr"/>
-          <a:lstStyle/>
-          <a:p>
-            <a:pPr marL="0" indent="0">
-              <a:buNone/>
-            </a:pPr>
-            <a:r>
-              <a:rPr lang="en-US" sz="1150" dirty="0">
-                <a:solidFill>
-                  <a:srgbClr val="1E293B"/>
-                </a:solidFill>
-                <a:latin typeface="Calibri" pitchFamily="34" charset="0"/>
-                <a:ea typeface="Calibri" pitchFamily="34" charset="-122"/>
-                <a:cs typeface="Calibri" pitchFamily="34" charset="-120"/>
-              </a:rPr>
-              <a:t>Output IPs</a:t>
-            </a:r>
-            <a:endParaRPr lang="en-US" sz="1150" dirty="0"/>
-          </a:p>
-        </p:txBody>
-      </p:sp>
-      <p:sp>
-        <p:nvSpPr>
-          <p:cNvPr id="20" name="Shape 18"/>
-          <p:cNvSpPr/>
-          <p:nvPr/>
-        </p:nvSpPr>
-        <p:spPr>
-          <a:xfrm>
-            <a:off x="2221992" y="1920240"/>
-            <a:ext cx="182880" cy="45720"/>
-          </a:xfrm>
-          <a:prstGeom prst="rect">
-            <a:avLst/>
-          </a:prstGeom>
-          <a:solidFill>
-            <a:srgbClr val="2196F3"/>
-          </a:solidFill>
-          <a:ln w="12700">
-            <a:solidFill>
-              <a:srgbClr val="2196F3"/>
-            </a:solidFill>
-            <a:prstDash val="solid"/>
-          </a:ln>
-        </p:spPr>
-      </p:sp>
-      <p:sp>
-        <p:nvSpPr>
-          <p:cNvPr id="21" name="Text 19"/>
-          <p:cNvSpPr/>
-          <p:nvPr/>
-        </p:nvSpPr>
-        <p:spPr>
-          <a:xfrm>
-            <a:off x="2258568" y="1810512"/>
-            <a:ext cx="182880" cy="256032"/>
-          </a:xfrm>
-          <a:prstGeom prst="rect">
-            <a:avLst/>
-          </a:prstGeom>
-          <a:noFill/>
-          <a:ln/>
-        </p:spPr>
-        <p:txBody>
-          <a:bodyPr wrap="square" rtlCol="0" anchor="ctr"/>
-          <a:lstStyle/>
-          <a:p>
-            <a:pPr marL="0" indent="0" algn="ctr">
-              <a:buNone/>
-            </a:pPr>
-            <a:r>
-              <a:rPr lang="en-US" sz="1400" dirty="0">
-                <a:solidFill>
-                  <a:srgbClr val="2196F3"/>
-                </a:solidFill>
-                <a:latin typeface="Calibri" pitchFamily="34" charset="0"/>
-                <a:ea typeface="Calibri" pitchFamily="34" charset="-122"/>
-                <a:cs typeface="Calibri" pitchFamily="34" charset="-120"/>
-              </a:rPr>
-              <a:t>▶</a:t>
-            </a:r>
-            <a:endParaRPr lang="en-US" sz="1400" dirty="0"/>
-          </a:p>
-        </p:txBody>
-      </p:sp>
-      <p:sp>
-        <p:nvSpPr>
-          <p:cNvPr id="22" name="Shape 20"/>
-          <p:cNvSpPr/>
-          <p:nvPr/>
-        </p:nvSpPr>
-        <p:spPr>
-          <a:xfrm>
-            <a:off x="2423160" y="1097280"/>
-            <a:ext cx="1920240" cy="365760"/>
-          </a:xfrm>
-          <a:prstGeom prst="rect">
-            <a:avLst/>
-          </a:prstGeom>
-          <a:solidFill>
-            <a:srgbClr val="EE0000"/>
-          </a:solidFill>
-          <a:ln w="12700">
-            <a:solidFill>
-              <a:srgbClr val="EE0000"/>
-            </a:solidFill>
-            <a:prstDash val="solid"/>
-          </a:ln>
-        </p:spPr>
-      </p:sp>
-      <p:sp>
-        <p:nvSpPr>
-          <p:cNvPr id="23" name="Text 21"/>
-          <p:cNvSpPr/>
-          <p:nvPr/>
-        </p:nvSpPr>
-        <p:spPr>
-          <a:xfrm>
-            <a:off x="2423160" y="1097280"/>
-            <a:ext cx="1920240" cy="365760"/>
-          </a:xfrm>
-          <a:prstGeom prst="rect">
-            <a:avLst/>
-          </a:prstGeom>
-          <a:noFill/>
-          <a:ln/>
-        </p:spPr>
-        <p:txBody>
-          <a:bodyPr wrap="square" rtlCol="0" anchor="ctr"/>
-          <a:lstStyle/>
-          <a:p>
-            <a:pPr marL="0" indent="0" algn="ctr">
-              <a:buNone/>
-            </a:pPr>
-            <a:r>
-              <a:rPr lang="en-US" sz="1000" b="1" dirty="0">
-                <a:solidFill>
-                  <a:srgbClr val="FFFFFF"/>
-                </a:solidFill>
-                <a:latin typeface="Calibri" pitchFamily="34" charset="0"/>
-                <a:ea typeface="Calibri" pitchFamily="34" charset="-122"/>
-                <a:cs typeface="Calibri" pitchFamily="34" charset="-120"/>
-              </a:rPr>
-              <a:t>ANSIBLE</a:t>
-            </a:r>
-            <a:endParaRPr lang="en-US" sz="1000" dirty="0"/>
-          </a:p>
-        </p:txBody>
-      </p:sp>
-      <p:sp>
-        <p:nvSpPr>
-          <p:cNvPr id="24" name="Shape 22"/>
-          <p:cNvSpPr/>
-          <p:nvPr/>
-        </p:nvSpPr>
-        <p:spPr>
-          <a:xfrm>
-            <a:off x="2423160" y="1600200"/>
-            <a:ext cx="1920240" cy="594360"/>
-          </a:xfrm>
-          <a:prstGeom prst="rect">
-            <a:avLst/>
-          </a:prstGeom>
-          <a:solidFill>
-            <a:srgbClr val="FFFFFF"/>
-          </a:solidFill>
-          <a:ln w="12700">
-            <a:solidFill>
-              <a:srgbClr val="BFDBFE"/>
-            </a:solidFill>
-            <a:prstDash val="solid"/>
-          </a:ln>
-          <a:effectLst>
-            <a:outerShdw blurRad="101600" dist="25400" dir="8100000" algn="bl" rotWithShape="0">
-              <a:srgbClr val="000000">
-                <a:alpha val="10000"/>
-              </a:srgbClr>
-            </a:outerShdw>
-          </a:effectLst>
-        </p:spPr>
-      </p:sp>
-      <p:sp>
-        <p:nvSpPr>
-          <p:cNvPr id="25" name="Shape 23"/>
-          <p:cNvSpPr/>
-          <p:nvPr/>
-        </p:nvSpPr>
-        <p:spPr>
-          <a:xfrm>
-            <a:off x="2423160" y="1600200"/>
-            <a:ext cx="64008" cy="594360"/>
-          </a:xfrm>
-          <a:prstGeom prst="rect">
-            <a:avLst/>
-          </a:prstGeom>
-          <a:solidFill>
-            <a:srgbClr val="EE0000"/>
-          </a:solidFill>
-          <a:ln w="12700">
-            <a:solidFill>
-              <a:srgbClr val="EE0000"/>
-            </a:solidFill>
-            <a:prstDash val="solid"/>
-          </a:ln>
-        </p:spPr>
-      </p:sp>
-      <p:sp>
-        <p:nvSpPr>
-          <p:cNvPr id="26" name="Text 24"/>
-          <p:cNvSpPr/>
-          <p:nvPr/>
-        </p:nvSpPr>
-        <p:spPr>
-          <a:xfrm>
-            <a:off x="2606040" y="1719072"/>
-            <a:ext cx="1645920" cy="347472"/>
-          </a:xfrm>
-          <a:prstGeom prst="rect">
-            <a:avLst/>
-          </a:prstGeom>
-          <a:noFill/>
-          <a:ln/>
-        </p:spPr>
-        <p:txBody>
-          <a:bodyPr wrap="square" lIns="0" tIns="0" rIns="0" bIns="0" rtlCol="0" anchor="ctr"/>
-          <a:lstStyle/>
-          <a:p>
-            <a:pPr marL="0" indent="0">
-              <a:buNone/>
-            </a:pPr>
-            <a:r>
-              <a:rPr lang="en-US" sz="1150" dirty="0">
-                <a:solidFill>
-                  <a:srgbClr val="1E293B"/>
-                </a:solidFill>
-                <a:latin typeface="Calibri" pitchFamily="34" charset="0"/>
-                <a:ea typeface="Calibri" pitchFamily="34" charset="-122"/>
-                <a:cs typeface="Calibri" pitchFamily="34" charset="-120"/>
-              </a:rPr>
-              <a:t>Inventory</a:t>
-            </a:r>
-            <a:endParaRPr lang="en-US" sz="1150" dirty="0"/>
-          </a:p>
-        </p:txBody>
-      </p:sp>
-      <p:sp>
-        <p:nvSpPr>
-          <p:cNvPr id="27" name="Shape 25"/>
-          <p:cNvSpPr/>
-          <p:nvPr/>
-        </p:nvSpPr>
-        <p:spPr>
-          <a:xfrm>
-            <a:off x="2423160" y="2313432"/>
-            <a:ext cx="1920240" cy="594360"/>
-          </a:xfrm>
-          <a:prstGeom prst="rect">
-            <a:avLst/>
-          </a:prstGeom>
-          <a:solidFill>
-            <a:srgbClr val="FFFFFF"/>
-          </a:solidFill>
-          <a:ln w="12700">
-            <a:solidFill>
-              <a:srgbClr val="BFDBFE"/>
-            </a:solidFill>
-            <a:prstDash val="solid"/>
-          </a:ln>
-          <a:effectLst>
-            <a:outerShdw blurRad="101600" dist="25400" dir="8100000" algn="bl" rotWithShape="0">
-              <a:srgbClr val="000000">
-                <a:alpha val="10000"/>
-              </a:srgbClr>
-            </a:outerShdw>
-          </a:effectLst>
-        </p:spPr>
-      </p:sp>
-      <p:sp>
-        <p:nvSpPr>
-          <p:cNvPr id="28" name="Shape 26"/>
-          <p:cNvSpPr/>
-          <p:nvPr/>
-        </p:nvSpPr>
-        <p:spPr>
-          <a:xfrm>
-            <a:off x="2423160" y="2313432"/>
-            <a:ext cx="64008" cy="594360"/>
-          </a:xfrm>
-          <a:prstGeom prst="rect">
-            <a:avLst/>
-          </a:prstGeom>
-          <a:solidFill>
-            <a:srgbClr val="EE0000"/>
-          </a:solidFill>
-          <a:ln w="12700">
-            <a:solidFill>
-              <a:srgbClr val="EE0000"/>
-            </a:solidFill>
-            <a:prstDash val="solid"/>
-          </a:ln>
-        </p:spPr>
-      </p:sp>
-      <p:sp>
-        <p:nvSpPr>
-          <p:cNvPr id="29" name="Text 27"/>
-          <p:cNvSpPr/>
-          <p:nvPr/>
-        </p:nvSpPr>
-        <p:spPr>
-          <a:xfrm>
-            <a:off x="2606040" y="2432304"/>
-            <a:ext cx="1645920" cy="347472"/>
-          </a:xfrm>
-          <a:prstGeom prst="rect">
-            <a:avLst/>
-          </a:prstGeom>
-          <a:noFill/>
-          <a:ln/>
-        </p:spPr>
-        <p:txBody>
-          <a:bodyPr wrap="square" lIns="0" tIns="0" rIns="0" bIns="0" rtlCol="0" anchor="ctr"/>
-          <a:lstStyle/>
-          <a:p>
-            <a:pPr marL="0" indent="0">
-              <a:buNone/>
-            </a:pPr>
-            <a:r>
-              <a:rPr lang="en-US" sz="1150" dirty="0">
-                <a:solidFill>
-                  <a:srgbClr val="1E293B"/>
-                </a:solidFill>
-                <a:latin typeface="Calibri" pitchFamily="34" charset="0"/>
-                <a:ea typeface="Calibri" pitchFamily="34" charset="-122"/>
-                <a:cs typeface="Calibri" pitchFamily="34" charset="-120"/>
-              </a:rPr>
-              <a:t>Install</a:t>
-            </a:r>
-            <a:endParaRPr lang="en-US" sz="1150" dirty="0"/>
-          </a:p>
-        </p:txBody>
-      </p:sp>
-      <p:sp>
-        <p:nvSpPr>
-          <p:cNvPr id="30" name="Shape 28"/>
-          <p:cNvSpPr/>
-          <p:nvPr/>
-        </p:nvSpPr>
-        <p:spPr>
-          <a:xfrm>
-            <a:off x="2423160" y="3026664"/>
-            <a:ext cx="1920240" cy="594360"/>
-          </a:xfrm>
-          <a:prstGeom prst="rect">
-            <a:avLst/>
-          </a:prstGeom>
-          <a:solidFill>
-            <a:srgbClr val="FFFFFF"/>
-          </a:solidFill>
-          <a:ln w="12700">
-            <a:solidFill>
-              <a:srgbClr val="BFDBFE"/>
-            </a:solidFill>
-            <a:prstDash val="solid"/>
-          </a:ln>
-          <a:effectLst>
-            <a:outerShdw blurRad="101600" dist="25400" dir="8100000" algn="bl" rotWithShape="0">
-              <a:srgbClr val="000000">
-                <a:alpha val="10000"/>
-              </a:srgbClr>
-            </a:outerShdw>
-          </a:effectLst>
-        </p:spPr>
-      </p:sp>
-      <p:sp>
-        <p:nvSpPr>
-          <p:cNvPr id="31" name="Shape 29"/>
-          <p:cNvSpPr/>
-          <p:nvPr/>
-        </p:nvSpPr>
-        <p:spPr>
-          <a:xfrm>
-            <a:off x="2423160" y="3026664"/>
-            <a:ext cx="64008" cy="594360"/>
-          </a:xfrm>
-          <a:prstGeom prst="rect">
-            <a:avLst/>
-          </a:prstGeom>
-          <a:solidFill>
-            <a:srgbClr val="EE0000"/>
-          </a:solidFill>
-          <a:ln w="12700">
-            <a:solidFill>
-              <a:srgbClr val="EE0000"/>
-            </a:solidFill>
-            <a:prstDash val="solid"/>
-          </a:ln>
-        </p:spPr>
-      </p:sp>
-      <p:sp>
-        <p:nvSpPr>
-          <p:cNvPr id="32" name="Text 30"/>
-          <p:cNvSpPr/>
-          <p:nvPr/>
-        </p:nvSpPr>
-        <p:spPr>
-          <a:xfrm>
-            <a:off x="2606040" y="3145536"/>
-            <a:ext cx="1645920" cy="347472"/>
-          </a:xfrm>
-          <a:prstGeom prst="rect">
-            <a:avLst/>
-          </a:prstGeom>
-          <a:noFill/>
-          <a:ln/>
-        </p:spPr>
-        <p:txBody>
-          <a:bodyPr wrap="square" lIns="0" tIns="0" rIns="0" bIns="0" rtlCol="0" anchor="ctr"/>
-          <a:lstStyle/>
-          <a:p>
-            <a:pPr marL="0" indent="0">
-              <a:buNone/>
-            </a:pPr>
-            <a:r>
-              <a:rPr lang="en-US" sz="1150" dirty="0">
-                <a:solidFill>
-                  <a:srgbClr val="1E293B"/>
-                </a:solidFill>
-                <a:latin typeface="Calibri" pitchFamily="34" charset="0"/>
-                <a:ea typeface="Calibri" pitchFamily="34" charset="-122"/>
-                <a:cs typeface="Calibri" pitchFamily="34" charset="-120"/>
-              </a:rPr>
-              <a:t>Configure</a:t>
-            </a:r>
-            <a:endParaRPr lang="en-US" sz="1150" dirty="0"/>
-          </a:p>
-        </p:txBody>
-      </p:sp>
-      <p:sp>
-        <p:nvSpPr>
-          <p:cNvPr id="33" name="Shape 31"/>
-          <p:cNvSpPr/>
-          <p:nvPr/>
-        </p:nvSpPr>
-        <p:spPr>
-          <a:xfrm>
-            <a:off x="2423160" y="3739896"/>
-            <a:ext cx="1920240" cy="594360"/>
-          </a:xfrm>
-          <a:prstGeom prst="rect">
-            <a:avLst/>
-          </a:prstGeom>
-          <a:solidFill>
-            <a:srgbClr val="FFFFFF"/>
-          </a:solidFill>
-          <a:ln w="12700">
-            <a:solidFill>
-              <a:srgbClr val="BFDBFE"/>
-            </a:solidFill>
-            <a:prstDash val="solid"/>
-          </a:ln>
-          <a:effectLst>
-            <a:outerShdw blurRad="101600" dist="25400" dir="8100000" algn="bl" rotWithShape="0">
-              <a:srgbClr val="000000">
-                <a:alpha val="10000"/>
-              </a:srgbClr>
-            </a:outerShdw>
-          </a:effectLst>
-        </p:spPr>
-      </p:sp>
-      <p:sp>
-        <p:nvSpPr>
-          <p:cNvPr id="34" name="Shape 32"/>
-          <p:cNvSpPr/>
-          <p:nvPr/>
-        </p:nvSpPr>
-        <p:spPr>
-          <a:xfrm>
-            <a:off x="2423160" y="3739896"/>
-            <a:ext cx="64008" cy="594360"/>
-          </a:xfrm>
-          <a:prstGeom prst="rect">
-            <a:avLst/>
-          </a:prstGeom>
-          <a:solidFill>
-            <a:srgbClr val="EE0000"/>
-          </a:solidFill>
-          <a:ln w="12700">
-            <a:solidFill>
-              <a:srgbClr val="EE0000"/>
-            </a:solidFill>
-            <a:prstDash val="solid"/>
-          </a:ln>
-        </p:spPr>
-      </p:sp>
-      <p:sp>
-        <p:nvSpPr>
-          <p:cNvPr id="35" name="Text 33"/>
-          <p:cNvSpPr/>
-          <p:nvPr/>
-        </p:nvSpPr>
-        <p:spPr>
-          <a:xfrm>
-            <a:off x="2606040" y="3858768"/>
-            <a:ext cx="1645920" cy="347472"/>
-          </a:xfrm>
-          <a:prstGeom prst="rect">
-            <a:avLst/>
-          </a:prstGeom>
-          <a:noFill/>
-          <a:ln/>
-        </p:spPr>
-        <p:txBody>
-          <a:bodyPr wrap="square" lIns="0" tIns="0" rIns="0" bIns="0" rtlCol="0" anchor="ctr"/>
-          <a:lstStyle/>
-          <a:p>
-            <a:pPr marL="0" indent="0">
-              <a:buNone/>
-            </a:pPr>
-            <a:r>
-              <a:rPr lang="en-US" sz="1150" dirty="0">
-                <a:solidFill>
-                  <a:srgbClr val="1E293B"/>
-                </a:solidFill>
-                <a:latin typeface="Calibri" pitchFamily="34" charset="0"/>
-                <a:ea typeface="Calibri" pitchFamily="34" charset="-122"/>
-                <a:cs typeface="Calibri" pitchFamily="34" charset="-120"/>
-              </a:rPr>
-              <a:t>K3s/Jenkins</a:t>
-            </a:r>
-            <a:endParaRPr lang="en-US" sz="1150" dirty="0"/>
-          </a:p>
-        </p:txBody>
-      </p:sp>
-      <p:sp>
-        <p:nvSpPr>
-          <p:cNvPr id="36" name="Shape 34"/>
-          <p:cNvSpPr/>
-          <p:nvPr/>
-        </p:nvSpPr>
-        <p:spPr>
-          <a:xfrm>
-            <a:off x="4370832" y="1920240"/>
-            <a:ext cx="182880" cy="45720"/>
-          </a:xfrm>
-          <a:prstGeom prst="rect">
-            <a:avLst/>
-          </a:prstGeom>
-          <a:solidFill>
-            <a:srgbClr val="2196F3"/>
-          </a:solidFill>
-          <a:ln w="12700">
-            <a:solidFill>
-              <a:srgbClr val="2196F3"/>
-            </a:solidFill>
-            <a:prstDash val="solid"/>
-          </a:ln>
-        </p:spPr>
-      </p:sp>
-      <p:sp>
-        <p:nvSpPr>
-          <p:cNvPr id="37" name="Text 35"/>
-          <p:cNvSpPr/>
-          <p:nvPr/>
-        </p:nvSpPr>
-        <p:spPr>
-          <a:xfrm>
-            <a:off x="4407408" y="1810512"/>
-            <a:ext cx="182880" cy="256032"/>
-          </a:xfrm>
-          <a:prstGeom prst="rect">
-            <a:avLst/>
-          </a:prstGeom>
-          <a:noFill/>
-          <a:ln/>
-        </p:spPr>
-        <p:txBody>
-          <a:bodyPr wrap="square" rtlCol="0" anchor="ctr"/>
-          <a:lstStyle/>
-          <a:p>
-            <a:pPr marL="0" indent="0" algn="ctr">
-              <a:buNone/>
-            </a:pPr>
-            <a:r>
-              <a:rPr lang="en-US" sz="1400" dirty="0">
-                <a:solidFill>
-                  <a:srgbClr val="2196F3"/>
-                </a:solidFill>
-                <a:latin typeface="Calibri" pitchFamily="34" charset="0"/>
-                <a:ea typeface="Calibri" pitchFamily="34" charset="-122"/>
-                <a:cs typeface="Calibri" pitchFamily="34" charset="-120"/>
-              </a:rPr>
-              <a:t>▶</a:t>
-            </a:r>
-            <a:endParaRPr lang="en-US" sz="1400" dirty="0"/>
-          </a:p>
-        </p:txBody>
-      </p:sp>
-      <p:sp>
-        <p:nvSpPr>
-          <p:cNvPr id="38" name="Shape 36"/>
-          <p:cNvSpPr/>
-          <p:nvPr/>
-        </p:nvSpPr>
-        <p:spPr>
-          <a:xfrm>
-            <a:off x="4572000" y="1097280"/>
-            <a:ext cx="1920240" cy="365760"/>
-          </a:xfrm>
-          <a:prstGeom prst="rect">
-            <a:avLst/>
-          </a:prstGeom>
-          <a:solidFill>
-            <a:srgbClr val="D33833"/>
-          </a:solidFill>
-          <a:ln w="12700">
-            <a:solidFill>
-              <a:srgbClr val="D33833"/>
-            </a:solidFill>
-            <a:prstDash val="solid"/>
-          </a:ln>
-        </p:spPr>
-      </p:sp>
-      <p:sp>
-        <p:nvSpPr>
-          <p:cNvPr id="39" name="Text 37"/>
-          <p:cNvSpPr/>
-          <p:nvPr/>
-        </p:nvSpPr>
-        <p:spPr>
-          <a:xfrm>
-            <a:off x="4572000" y="1097280"/>
-            <a:ext cx="1920240" cy="365760"/>
-          </a:xfrm>
-          <a:prstGeom prst="rect">
-            <a:avLst/>
-          </a:prstGeom>
-          <a:noFill/>
-          <a:ln/>
-        </p:spPr>
-        <p:txBody>
-          <a:bodyPr wrap="square" rtlCol="0" anchor="ctr"/>
-          <a:lstStyle/>
-          <a:p>
-            <a:pPr marL="0" indent="0" algn="ctr">
-              <a:buNone/>
-            </a:pPr>
-            <a:r>
-              <a:rPr lang="en-US" sz="1000" b="1" dirty="0">
-                <a:solidFill>
-                  <a:srgbClr val="FFFFFF"/>
-                </a:solidFill>
-                <a:latin typeface="Calibri" pitchFamily="34" charset="0"/>
-                <a:ea typeface="Calibri" pitchFamily="34" charset="-122"/>
-                <a:cs typeface="Calibri" pitchFamily="34" charset="-120"/>
-              </a:rPr>
-              <a:t>JENKINS CI/CD</a:t>
-            </a:r>
-            <a:endParaRPr lang="en-US" sz="1000" dirty="0"/>
-          </a:p>
-        </p:txBody>
-      </p:sp>
-      <p:sp>
-        <p:nvSpPr>
-          <p:cNvPr id="40" name="Shape 38"/>
-          <p:cNvSpPr/>
-          <p:nvPr/>
-        </p:nvSpPr>
-        <p:spPr>
-          <a:xfrm>
-            <a:off x="4572000" y="1600200"/>
-            <a:ext cx="1920240" cy="594360"/>
-          </a:xfrm>
-          <a:prstGeom prst="rect">
-            <a:avLst/>
-          </a:prstGeom>
-          <a:solidFill>
-            <a:srgbClr val="FFFFFF"/>
-          </a:solidFill>
-          <a:ln w="12700">
-            <a:solidFill>
-              <a:srgbClr val="BFDBFE"/>
-            </a:solidFill>
-            <a:prstDash val="solid"/>
-          </a:ln>
-          <a:effectLst>
-            <a:outerShdw blurRad="101600" dist="25400" dir="8100000" algn="bl" rotWithShape="0">
-              <a:srgbClr val="000000">
-                <a:alpha val="10000"/>
-              </a:srgbClr>
-            </a:outerShdw>
-          </a:effectLst>
-        </p:spPr>
-      </p:sp>
-      <p:sp>
-        <p:nvSpPr>
-          <p:cNvPr id="41" name="Shape 39"/>
-          <p:cNvSpPr/>
-          <p:nvPr/>
-        </p:nvSpPr>
-        <p:spPr>
-          <a:xfrm>
-            <a:off x="4572000" y="1600200"/>
-            <a:ext cx="64008" cy="594360"/>
-          </a:xfrm>
-          <a:prstGeom prst="rect">
-            <a:avLst/>
-          </a:prstGeom>
-          <a:solidFill>
-            <a:srgbClr val="D33833"/>
-          </a:solidFill>
-          <a:ln w="12700">
-            <a:solidFill>
-              <a:srgbClr val="D33833"/>
-            </a:solidFill>
-            <a:prstDash val="solid"/>
-          </a:ln>
-        </p:spPr>
-      </p:sp>
-      <p:sp>
-        <p:nvSpPr>
-          <p:cNvPr id="42" name="Text 40"/>
-          <p:cNvSpPr/>
-          <p:nvPr/>
-        </p:nvSpPr>
-        <p:spPr>
-          <a:xfrm>
-            <a:off x="4754880" y="1719072"/>
-            <a:ext cx="1645920" cy="347472"/>
-          </a:xfrm>
-          <a:prstGeom prst="rect">
-            <a:avLst/>
-          </a:prstGeom>
-          <a:noFill/>
-          <a:ln/>
-        </p:spPr>
-        <p:txBody>
-          <a:bodyPr wrap="square" lIns="0" tIns="0" rIns="0" bIns="0" rtlCol="0" anchor="ctr"/>
-          <a:lstStyle/>
-          <a:p>
-            <a:pPr marL="0" indent="0">
-              <a:buNone/>
-            </a:pPr>
-            <a:r>
-              <a:rPr lang="en-US" sz="1150" dirty="0">
-                <a:solidFill>
-                  <a:srgbClr val="1E293B"/>
-                </a:solidFill>
-                <a:latin typeface="Calibri" pitchFamily="34" charset="0"/>
-                <a:ea typeface="Calibri" pitchFamily="34" charset="-122"/>
-                <a:cs typeface="Calibri" pitchFamily="34" charset="-120"/>
-              </a:rPr>
-              <a:t>Checkout</a:t>
-            </a:r>
-            <a:endParaRPr lang="en-US" sz="1150" dirty="0"/>
-          </a:p>
-        </p:txBody>
-      </p:sp>
-      <p:sp>
-        <p:nvSpPr>
-          <p:cNvPr id="43" name="Shape 41"/>
-          <p:cNvSpPr/>
-          <p:nvPr/>
-        </p:nvSpPr>
-        <p:spPr>
-          <a:xfrm>
-            <a:off x="4572000" y="2313432"/>
-            <a:ext cx="1920240" cy="594360"/>
-          </a:xfrm>
-          <a:prstGeom prst="rect">
-            <a:avLst/>
-          </a:prstGeom>
-          <a:solidFill>
-            <a:srgbClr val="FFFFFF"/>
-          </a:solidFill>
-          <a:ln w="12700">
-            <a:solidFill>
-              <a:srgbClr val="BFDBFE"/>
-            </a:solidFill>
-            <a:prstDash val="solid"/>
-          </a:ln>
-          <a:effectLst>
-            <a:outerShdw blurRad="101600" dist="25400" dir="8100000" algn="bl" rotWithShape="0">
-              <a:srgbClr val="000000">
-                <a:alpha val="10000"/>
-              </a:srgbClr>
-            </a:outerShdw>
-          </a:effectLst>
-        </p:spPr>
-      </p:sp>
-      <p:sp>
-        <p:nvSpPr>
-          <p:cNvPr id="44" name="Shape 42"/>
-          <p:cNvSpPr/>
-          <p:nvPr/>
-        </p:nvSpPr>
-        <p:spPr>
-          <a:xfrm>
-            <a:off x="4572000" y="2313432"/>
-            <a:ext cx="64008" cy="594360"/>
-          </a:xfrm>
-          <a:prstGeom prst="rect">
-            <a:avLst/>
-          </a:prstGeom>
-          <a:solidFill>
-            <a:srgbClr val="D33833"/>
-          </a:solidFill>
-          <a:ln w="12700">
-            <a:solidFill>
-              <a:srgbClr val="D33833"/>
-            </a:solidFill>
-            <a:prstDash val="solid"/>
-          </a:ln>
-        </p:spPr>
-      </p:sp>
-      <p:sp>
-        <p:nvSpPr>
-          <p:cNvPr id="45" name="Text 43"/>
-          <p:cNvSpPr/>
-          <p:nvPr/>
-        </p:nvSpPr>
-        <p:spPr>
-          <a:xfrm>
-            <a:off x="4754880" y="2432304"/>
-            <a:ext cx="1645920" cy="347472"/>
-          </a:xfrm>
-          <a:prstGeom prst="rect">
-            <a:avLst/>
-          </a:prstGeom>
-          <a:noFill/>
-          <a:ln/>
-        </p:spPr>
-        <p:txBody>
-          <a:bodyPr wrap="square" lIns="0" tIns="0" rIns="0" bIns="0" rtlCol="0" anchor="ctr"/>
-          <a:lstStyle/>
-          <a:p>
-            <a:pPr marL="0" indent="0">
-              <a:buNone/>
-            </a:pPr>
-            <a:r>
-              <a:rPr lang="en-US" sz="1150" dirty="0">
-                <a:solidFill>
-                  <a:srgbClr val="1E293B"/>
-                </a:solidFill>
-                <a:latin typeface="Calibri" pitchFamily="34" charset="0"/>
-                <a:ea typeface="Calibri" pitchFamily="34" charset="-122"/>
-                <a:cs typeface="Calibri" pitchFamily="34" charset="-120"/>
-              </a:rPr>
-              <a:t>Docker Build</a:t>
-            </a:r>
-            <a:endParaRPr lang="en-US" sz="1150" dirty="0"/>
-          </a:p>
-        </p:txBody>
-      </p:sp>
-      <p:sp>
-        <p:nvSpPr>
-          <p:cNvPr id="46" name="Shape 44"/>
-          <p:cNvSpPr/>
-          <p:nvPr/>
-        </p:nvSpPr>
-        <p:spPr>
-          <a:xfrm>
-            <a:off x="4572000" y="3026664"/>
-            <a:ext cx="1920240" cy="594360"/>
-          </a:xfrm>
-          <a:prstGeom prst="rect">
-            <a:avLst/>
-          </a:prstGeom>
-          <a:solidFill>
-            <a:srgbClr val="FFFFFF"/>
-          </a:solidFill>
-          <a:ln w="12700">
-            <a:solidFill>
-              <a:srgbClr val="BFDBFE"/>
-            </a:solidFill>
-            <a:prstDash val="solid"/>
-          </a:ln>
-          <a:effectLst>
-            <a:outerShdw blurRad="101600" dist="25400" dir="8100000" algn="bl" rotWithShape="0">
-              <a:srgbClr val="000000">
-                <a:alpha val="10000"/>
-              </a:srgbClr>
-            </a:outerShdw>
-          </a:effectLst>
-        </p:spPr>
-      </p:sp>
-      <p:sp>
-        <p:nvSpPr>
-          <p:cNvPr id="47" name="Shape 45"/>
-          <p:cNvSpPr/>
-          <p:nvPr/>
-        </p:nvSpPr>
-        <p:spPr>
-          <a:xfrm>
-            <a:off x="4572000" y="3026664"/>
-            <a:ext cx="64008" cy="594360"/>
-          </a:xfrm>
-          <a:prstGeom prst="rect">
-            <a:avLst/>
-          </a:prstGeom>
-          <a:solidFill>
-            <a:srgbClr val="D33833"/>
-          </a:solidFill>
-          <a:ln w="12700">
-            <a:solidFill>
-              <a:srgbClr val="D33833"/>
-            </a:solidFill>
-            <a:prstDash val="solid"/>
-          </a:ln>
-        </p:spPr>
-      </p:sp>
-      <p:sp>
-        <p:nvSpPr>
-          <p:cNvPr id="48" name="Text 46"/>
-          <p:cNvSpPr/>
-          <p:nvPr/>
-        </p:nvSpPr>
-        <p:spPr>
-          <a:xfrm>
-            <a:off x="4754880" y="3145536"/>
-            <a:ext cx="1645920" cy="347472"/>
-          </a:xfrm>
-          <a:prstGeom prst="rect">
-            <a:avLst/>
-          </a:prstGeom>
-          <a:noFill/>
-          <a:ln/>
-        </p:spPr>
-        <p:txBody>
-          <a:bodyPr wrap="square" lIns="0" tIns="0" rIns="0" bIns="0" rtlCol="0" anchor="ctr"/>
-          <a:lstStyle/>
-          <a:p>
-            <a:pPr marL="0" indent="0">
-              <a:buNone/>
-            </a:pPr>
-            <a:r>
-              <a:rPr lang="en-US" sz="1150" dirty="0">
-                <a:solidFill>
-                  <a:srgbClr val="1E293B"/>
-                </a:solidFill>
-                <a:latin typeface="Calibri" pitchFamily="34" charset="0"/>
-                <a:ea typeface="Calibri" pitchFamily="34" charset="-122"/>
-                <a:cs typeface="Calibri" pitchFamily="34" charset="-120"/>
-              </a:rPr>
-              <a:t>Push Image</a:t>
-            </a:r>
-            <a:endParaRPr lang="en-US" sz="1150" dirty="0"/>
-          </a:p>
-        </p:txBody>
-      </p:sp>
-      <p:sp>
-        <p:nvSpPr>
-          <p:cNvPr id="49" name="Shape 47"/>
-          <p:cNvSpPr/>
-          <p:nvPr/>
-        </p:nvSpPr>
-        <p:spPr>
-          <a:xfrm>
-            <a:off x="4572000" y="3739896"/>
-            <a:ext cx="1920240" cy="594360"/>
-          </a:xfrm>
-          <a:prstGeom prst="rect">
-            <a:avLst/>
-          </a:prstGeom>
-          <a:solidFill>
-            <a:srgbClr val="FFFFFF"/>
-          </a:solidFill>
-          <a:ln w="12700">
-            <a:solidFill>
-              <a:srgbClr val="BFDBFE"/>
-            </a:solidFill>
-            <a:prstDash val="solid"/>
-          </a:ln>
-          <a:effectLst>
-            <a:outerShdw blurRad="101600" dist="25400" dir="8100000" algn="bl" rotWithShape="0">
-              <a:srgbClr val="000000">
-                <a:alpha val="10000"/>
-              </a:srgbClr>
-            </a:outerShdw>
-          </a:effectLst>
-        </p:spPr>
-      </p:sp>
-      <p:sp>
-        <p:nvSpPr>
-          <p:cNvPr id="50" name="Shape 48"/>
-          <p:cNvSpPr/>
-          <p:nvPr/>
-        </p:nvSpPr>
-        <p:spPr>
-          <a:xfrm>
-            <a:off x="4572000" y="3739896"/>
-            <a:ext cx="64008" cy="594360"/>
-          </a:xfrm>
-          <a:prstGeom prst="rect">
-            <a:avLst/>
-          </a:prstGeom>
-          <a:solidFill>
-            <a:srgbClr val="D33833"/>
-          </a:solidFill>
-          <a:ln w="12700">
-            <a:solidFill>
-              <a:srgbClr val="D33833"/>
-            </a:solidFill>
-            <a:prstDash val="solid"/>
-          </a:ln>
-        </p:spPr>
-      </p:sp>
-      <p:sp>
-        <p:nvSpPr>
-          <p:cNvPr id="51" name="Text 49"/>
-          <p:cNvSpPr/>
-          <p:nvPr/>
-        </p:nvSpPr>
-        <p:spPr>
-          <a:xfrm>
-            <a:off x="4754880" y="3858768"/>
-            <a:ext cx="1645920" cy="347472"/>
-          </a:xfrm>
-          <a:prstGeom prst="rect">
-            <a:avLst/>
-          </a:prstGeom>
-          <a:noFill/>
-          <a:ln/>
-        </p:spPr>
-        <p:txBody>
-          <a:bodyPr wrap="square" lIns="0" tIns="0" rIns="0" bIns="0" rtlCol="0" anchor="ctr"/>
-          <a:lstStyle/>
-          <a:p>
-            <a:pPr marL="0" indent="0">
-              <a:buNone/>
-            </a:pPr>
-            <a:r>
-              <a:rPr lang="en-US" sz="1150" dirty="0">
-                <a:solidFill>
-                  <a:srgbClr val="1E293B"/>
-                </a:solidFill>
-                <a:latin typeface="Calibri" pitchFamily="34" charset="0"/>
-                <a:ea typeface="Calibri" pitchFamily="34" charset="-122"/>
-                <a:cs typeface="Calibri" pitchFamily="34" charset="-120"/>
-              </a:rPr>
-              <a:t>Deploy</a:t>
-            </a:r>
-            <a:endParaRPr lang="en-US" sz="1150" dirty="0"/>
-          </a:p>
-        </p:txBody>
-      </p:sp>
-      <p:sp>
-        <p:nvSpPr>
-          <p:cNvPr id="52" name="Shape 50"/>
-          <p:cNvSpPr/>
-          <p:nvPr/>
-        </p:nvSpPr>
-        <p:spPr>
-          <a:xfrm>
-            <a:off x="6519672" y="1920240"/>
-            <a:ext cx="182880" cy="45720"/>
-          </a:xfrm>
-          <a:prstGeom prst="rect">
-            <a:avLst/>
-          </a:prstGeom>
-          <a:solidFill>
-            <a:srgbClr val="2196F3"/>
-          </a:solidFill>
-          <a:ln w="12700">
-            <a:solidFill>
-              <a:srgbClr val="2196F3"/>
-            </a:solidFill>
-            <a:prstDash val="solid"/>
-          </a:ln>
-        </p:spPr>
-      </p:sp>
-      <p:sp>
-        <p:nvSpPr>
-          <p:cNvPr id="53" name="Text 51"/>
-          <p:cNvSpPr/>
-          <p:nvPr/>
-        </p:nvSpPr>
-        <p:spPr>
-          <a:xfrm>
-            <a:off x="6556248" y="1810512"/>
-            <a:ext cx="182880" cy="256032"/>
-          </a:xfrm>
-          <a:prstGeom prst="rect">
-            <a:avLst/>
-          </a:prstGeom>
-          <a:noFill/>
-          <a:ln/>
-        </p:spPr>
-        <p:txBody>
-          <a:bodyPr wrap="square" rtlCol="0" anchor="ctr"/>
-          <a:lstStyle/>
-          <a:p>
-            <a:pPr marL="0" indent="0" algn="ctr">
-              <a:buNone/>
-            </a:pPr>
-            <a:r>
-              <a:rPr lang="en-US" sz="1400" dirty="0">
-                <a:solidFill>
-                  <a:srgbClr val="2196F3"/>
-                </a:solidFill>
-                <a:latin typeface="Calibri" pitchFamily="34" charset="0"/>
-                <a:ea typeface="Calibri" pitchFamily="34" charset="-122"/>
-                <a:cs typeface="Calibri" pitchFamily="34" charset="-120"/>
-              </a:rPr>
-              <a:t>▶</a:t>
-            </a:r>
-            <a:endParaRPr lang="en-US" sz="1400" dirty="0"/>
-          </a:p>
-        </p:txBody>
-      </p:sp>
-      <p:sp>
-        <p:nvSpPr>
-          <p:cNvPr id="54" name="Shape 52"/>
-          <p:cNvSpPr/>
-          <p:nvPr/>
-        </p:nvSpPr>
-        <p:spPr>
-          <a:xfrm>
-            <a:off x="6720840" y="1097280"/>
-            <a:ext cx="1920240" cy="365760"/>
-          </a:xfrm>
-          <a:prstGeom prst="rect">
-            <a:avLst/>
-          </a:prstGeom>
-          <a:solidFill>
-            <a:srgbClr val="326CE5"/>
-          </a:solidFill>
-          <a:ln w="12700">
-            <a:solidFill>
-              <a:srgbClr val="326CE5"/>
-            </a:solidFill>
-            <a:prstDash val="solid"/>
-          </a:ln>
-        </p:spPr>
-      </p:sp>
-      <p:sp>
-        <p:nvSpPr>
-          <p:cNvPr id="55" name="Text 53"/>
-          <p:cNvSpPr/>
-          <p:nvPr/>
-        </p:nvSpPr>
-        <p:spPr>
-          <a:xfrm>
-            <a:off x="6720840" y="1097280"/>
-            <a:ext cx="1920240" cy="365760"/>
-          </a:xfrm>
-          <a:prstGeom prst="rect">
-            <a:avLst/>
-          </a:prstGeom>
-          <a:noFill/>
-          <a:ln/>
-        </p:spPr>
-        <p:txBody>
-          <a:bodyPr wrap="square" rtlCol="0" anchor="ctr"/>
-          <a:lstStyle/>
-          <a:p>
-            <a:pPr marL="0" indent="0" algn="ctr">
-              <a:buNone/>
-            </a:pPr>
-            <a:r>
-              <a:rPr lang="en-US" sz="1000" b="1" dirty="0">
-                <a:solidFill>
-                  <a:srgbClr val="FFFFFF"/>
-                </a:solidFill>
-                <a:latin typeface="Calibri" pitchFamily="34" charset="0"/>
-                <a:ea typeface="Calibri" pitchFamily="34" charset="-122"/>
-                <a:cs typeface="Calibri" pitchFamily="34" charset="-120"/>
-              </a:rPr>
-              <a:t>K3S CLUSTER</a:t>
-            </a:r>
-            <a:endParaRPr lang="en-US" sz="1000" dirty="0"/>
-          </a:p>
-        </p:txBody>
-      </p:sp>
-      <p:sp>
-        <p:nvSpPr>
-          <p:cNvPr id="56" name="Shape 54"/>
-          <p:cNvSpPr/>
-          <p:nvPr/>
-        </p:nvSpPr>
-        <p:spPr>
-          <a:xfrm>
-            <a:off x="6720840" y="1600200"/>
-            <a:ext cx="1920240" cy="594360"/>
-          </a:xfrm>
-          <a:prstGeom prst="rect">
-            <a:avLst/>
-          </a:prstGeom>
-          <a:solidFill>
-            <a:srgbClr val="FFFFFF"/>
-          </a:solidFill>
-          <a:ln w="12700">
-            <a:solidFill>
-              <a:srgbClr val="BFDBFE"/>
-            </a:solidFill>
-            <a:prstDash val="solid"/>
-          </a:ln>
-          <a:effectLst>
-            <a:outerShdw blurRad="101600" dist="25400" dir="8100000" algn="bl" rotWithShape="0">
-              <a:srgbClr val="000000">
-                <a:alpha val="10000"/>
-              </a:srgbClr>
-            </a:outerShdw>
-          </a:effectLst>
-        </p:spPr>
-      </p:sp>
-      <p:sp>
-        <p:nvSpPr>
-          <p:cNvPr id="57" name="Shape 55"/>
-          <p:cNvSpPr/>
-          <p:nvPr/>
-        </p:nvSpPr>
-        <p:spPr>
-          <a:xfrm>
-            <a:off x="6720840" y="1600200"/>
-            <a:ext cx="64008" cy="594360"/>
-          </a:xfrm>
-          <a:prstGeom prst="rect">
-            <a:avLst/>
-          </a:prstGeom>
-          <a:solidFill>
-            <a:srgbClr val="326CE5"/>
-          </a:solidFill>
-          <a:ln w="12700">
-            <a:solidFill>
-              <a:srgbClr val="326CE5"/>
-            </a:solidFill>
-            <a:prstDash val="solid"/>
-          </a:ln>
-        </p:spPr>
-      </p:sp>
-      <p:sp>
-        <p:nvSpPr>
-          <p:cNvPr id="58" name="Text 56"/>
-          <p:cNvSpPr/>
-          <p:nvPr/>
-        </p:nvSpPr>
-        <p:spPr>
-          <a:xfrm>
-            <a:off x="6903720" y="1719072"/>
-            <a:ext cx="1645920" cy="347472"/>
-          </a:xfrm>
-          <a:prstGeom prst="rect">
-            <a:avLst/>
-          </a:prstGeom>
-          <a:noFill/>
-          <a:ln/>
-        </p:spPr>
-        <p:txBody>
-          <a:bodyPr wrap="square" lIns="0" tIns="0" rIns="0" bIns="0" rtlCol="0" anchor="ctr"/>
-          <a:lstStyle/>
-          <a:p>
-            <a:pPr marL="0" indent="0">
-              <a:buNone/>
-            </a:pPr>
-            <a:r>
-              <a:rPr lang="en-US" sz="1150" dirty="0">
-                <a:solidFill>
-                  <a:srgbClr val="1E293B"/>
-                </a:solidFill>
-                <a:latin typeface="Calibri" pitchFamily="34" charset="0"/>
-                <a:ea typeface="Calibri" pitchFamily="34" charset="-122"/>
-                <a:cs typeface="Calibri" pitchFamily="34" charset="-120"/>
-              </a:rPr>
-              <a:t>Deployment</a:t>
-            </a:r>
-            <a:endParaRPr lang="en-US" sz="1150" dirty="0"/>
-          </a:p>
-        </p:txBody>
-      </p:sp>
-      <p:sp>
-        <p:nvSpPr>
-          <p:cNvPr id="59" name="Shape 57"/>
-          <p:cNvSpPr/>
-          <p:nvPr/>
-        </p:nvSpPr>
-        <p:spPr>
-          <a:xfrm>
-            <a:off x="6720840" y="2313432"/>
-            <a:ext cx="1920240" cy="594360"/>
-          </a:xfrm>
-          <a:prstGeom prst="rect">
-            <a:avLst/>
-          </a:prstGeom>
-          <a:solidFill>
-            <a:srgbClr val="FFFFFF"/>
-          </a:solidFill>
-          <a:ln w="12700">
-            <a:solidFill>
-              <a:srgbClr val="BFDBFE"/>
-            </a:solidFill>
-            <a:prstDash val="solid"/>
-          </a:ln>
-          <a:effectLst>
-            <a:outerShdw blurRad="101600" dist="25400" dir="8100000" algn="bl" rotWithShape="0">
-              <a:srgbClr val="000000">
-                <a:alpha val="10000"/>
-              </a:srgbClr>
-            </a:outerShdw>
-          </a:effectLst>
-        </p:spPr>
-      </p:sp>
-      <p:sp>
-        <p:nvSpPr>
-          <p:cNvPr id="60" name="Shape 58"/>
-          <p:cNvSpPr/>
-          <p:nvPr/>
-        </p:nvSpPr>
-        <p:spPr>
-          <a:xfrm>
-            <a:off x="6720840" y="2313432"/>
-            <a:ext cx="64008" cy="594360"/>
-          </a:xfrm>
-          <a:prstGeom prst="rect">
-            <a:avLst/>
-          </a:prstGeom>
-          <a:solidFill>
-            <a:srgbClr val="326CE5"/>
-          </a:solidFill>
-          <a:ln w="12700">
-            <a:solidFill>
-              <a:srgbClr val="326CE5"/>
-            </a:solidFill>
-            <a:prstDash val="solid"/>
-          </a:ln>
-        </p:spPr>
-      </p:sp>
-      <p:sp>
-        <p:nvSpPr>
-          <p:cNvPr id="61" name="Text 59"/>
-          <p:cNvSpPr/>
-          <p:nvPr/>
-        </p:nvSpPr>
-        <p:spPr>
-          <a:xfrm>
-            <a:off x="6903720" y="2432304"/>
-            <a:ext cx="1645920" cy="347472"/>
-          </a:xfrm>
-          <a:prstGeom prst="rect">
-            <a:avLst/>
-          </a:prstGeom>
-          <a:noFill/>
-          <a:ln/>
-        </p:spPr>
-        <p:txBody>
-          <a:bodyPr wrap="square" lIns="0" tIns="0" rIns="0" bIns="0" rtlCol="0" anchor="ctr"/>
-          <a:lstStyle/>
-          <a:p>
-            <a:pPr marL="0" indent="0">
-              <a:buNone/>
-            </a:pPr>
-            <a:r>
-              <a:rPr lang="en-US" sz="1150" dirty="0">
-                <a:solidFill>
-                  <a:srgbClr val="1E293B"/>
-                </a:solidFill>
-                <a:latin typeface="Calibri" pitchFamily="34" charset="0"/>
-                <a:ea typeface="Calibri" pitchFamily="34" charset="-122"/>
-                <a:cs typeface="Calibri" pitchFamily="34" charset="-120"/>
-              </a:rPr>
-              <a:t>Pod</a:t>
-            </a:r>
-            <a:endParaRPr lang="en-US" sz="1150" dirty="0"/>
-          </a:p>
-        </p:txBody>
-      </p:sp>
-      <p:sp>
-        <p:nvSpPr>
-          <p:cNvPr id="62" name="Shape 60"/>
-          <p:cNvSpPr/>
-          <p:nvPr/>
-        </p:nvSpPr>
-        <p:spPr>
-          <a:xfrm>
-            <a:off x="6720840" y="3026664"/>
-            <a:ext cx="1920240" cy="594360"/>
-          </a:xfrm>
-          <a:prstGeom prst="rect">
-            <a:avLst/>
-          </a:prstGeom>
-          <a:solidFill>
-            <a:srgbClr val="FFFFFF"/>
-          </a:solidFill>
-          <a:ln w="12700">
-            <a:solidFill>
-              <a:srgbClr val="BFDBFE"/>
-            </a:solidFill>
-            <a:prstDash val="solid"/>
-          </a:ln>
-          <a:effectLst>
-            <a:outerShdw blurRad="101600" dist="25400" dir="8100000" algn="bl" rotWithShape="0">
-              <a:srgbClr val="000000">
-                <a:alpha val="10000"/>
-              </a:srgbClr>
-            </a:outerShdw>
-          </a:effectLst>
-        </p:spPr>
-      </p:sp>
-      <p:sp>
-        <p:nvSpPr>
-          <p:cNvPr id="63" name="Shape 61"/>
-          <p:cNvSpPr/>
-          <p:nvPr/>
-        </p:nvSpPr>
-        <p:spPr>
-          <a:xfrm>
-            <a:off x="6720840" y="3026664"/>
-            <a:ext cx="64008" cy="594360"/>
-          </a:xfrm>
-          <a:prstGeom prst="rect">
-            <a:avLst/>
-          </a:prstGeom>
-          <a:solidFill>
-            <a:srgbClr val="326CE5"/>
-          </a:solidFill>
-          <a:ln w="12700">
-            <a:solidFill>
-              <a:srgbClr val="326CE5"/>
-            </a:solidFill>
-            <a:prstDash val="solid"/>
-          </a:ln>
-        </p:spPr>
-      </p:sp>
-      <p:sp>
-        <p:nvSpPr>
-          <p:cNvPr id="64" name="Text 62"/>
-          <p:cNvSpPr/>
-          <p:nvPr/>
-        </p:nvSpPr>
-        <p:spPr>
-          <a:xfrm>
-            <a:off x="6903720" y="3145536"/>
-            <a:ext cx="1645920" cy="347472"/>
-          </a:xfrm>
-          <a:prstGeom prst="rect">
-            <a:avLst/>
-          </a:prstGeom>
-          <a:noFill/>
-          <a:ln/>
-        </p:spPr>
-        <p:txBody>
-          <a:bodyPr wrap="square" lIns="0" tIns="0" rIns="0" bIns="0" rtlCol="0" anchor="ctr"/>
-          <a:lstStyle/>
-          <a:p>
-            <a:pPr marL="0" indent="0">
-              <a:buNone/>
-            </a:pPr>
-            <a:r>
-              <a:rPr lang="en-US" sz="1150" dirty="0">
-                <a:solidFill>
-                  <a:srgbClr val="1E293B"/>
-                </a:solidFill>
-                <a:latin typeface="Calibri" pitchFamily="34" charset="0"/>
-                <a:ea typeface="Calibri" pitchFamily="34" charset="-122"/>
-                <a:cs typeface="Calibri" pitchFamily="34" charset="-120"/>
-              </a:rPr>
-              <a:t>NodePort</a:t>
-            </a:r>
-            <a:endParaRPr lang="en-US" sz="1150" dirty="0"/>
-          </a:p>
-        </p:txBody>
-      </p:sp>
-      <p:sp>
-        <p:nvSpPr>
-          <p:cNvPr id="65" name="Shape 63"/>
-          <p:cNvSpPr/>
-          <p:nvPr/>
-        </p:nvSpPr>
-        <p:spPr>
-          <a:xfrm>
-            <a:off x="6720840" y="3739896"/>
-            <a:ext cx="1920240" cy="594360"/>
-          </a:xfrm>
-          <a:prstGeom prst="rect">
-            <a:avLst/>
-          </a:prstGeom>
-          <a:solidFill>
-            <a:srgbClr val="FFFFFF"/>
-          </a:solidFill>
-          <a:ln w="12700">
-            <a:solidFill>
-              <a:srgbClr val="BFDBFE"/>
-            </a:solidFill>
-            <a:prstDash val="solid"/>
-          </a:ln>
-          <a:effectLst>
-            <a:outerShdw blurRad="101600" dist="25400" dir="8100000" algn="bl" rotWithShape="0">
-              <a:srgbClr val="000000">
-                <a:alpha val="10000"/>
-              </a:srgbClr>
-            </a:outerShdw>
-          </a:effectLst>
-        </p:spPr>
-      </p:sp>
-      <p:sp>
-        <p:nvSpPr>
-          <p:cNvPr id="66" name="Shape 64"/>
-          <p:cNvSpPr/>
-          <p:nvPr/>
-        </p:nvSpPr>
-        <p:spPr>
-          <a:xfrm>
-            <a:off x="6720840" y="3739896"/>
-            <a:ext cx="64008" cy="594360"/>
-          </a:xfrm>
-          <a:prstGeom prst="rect">
-            <a:avLst/>
-          </a:prstGeom>
-          <a:solidFill>
-            <a:srgbClr val="326CE5"/>
-          </a:solidFill>
-          <a:ln w="12700">
-            <a:solidFill>
-              <a:srgbClr val="326CE5"/>
-            </a:solidFill>
-            <a:prstDash val="solid"/>
-          </a:ln>
-        </p:spPr>
-      </p:sp>
-      <p:sp>
-        <p:nvSpPr>
-          <p:cNvPr id="67" name="Text 65"/>
-          <p:cNvSpPr/>
-          <p:nvPr/>
-        </p:nvSpPr>
-        <p:spPr>
-          <a:xfrm>
-            <a:off x="6903720" y="3858768"/>
-            <a:ext cx="1645920" cy="347472"/>
-          </a:xfrm>
-          <a:prstGeom prst="rect">
-            <a:avLst/>
-          </a:prstGeom>
-          <a:noFill/>
-          <a:ln/>
-        </p:spPr>
-        <p:txBody>
-          <a:bodyPr wrap="square" lIns="0" tIns="0" rIns="0" bIns="0" rtlCol="0" anchor="ctr"/>
-          <a:lstStyle/>
-          <a:p>
-            <a:pPr marL="0" indent="0">
-              <a:buNone/>
-            </a:pPr>
-            <a:r>
-              <a:rPr lang="en-US" sz="1150" dirty="0">
-                <a:solidFill>
-                  <a:srgbClr val="1E293B"/>
-                </a:solidFill>
-                <a:latin typeface="Calibri" pitchFamily="34" charset="0"/>
-                <a:ea typeface="Calibri" pitchFamily="34" charset="-122"/>
-                <a:cs typeface="Calibri" pitchFamily="34" charset="-120"/>
-              </a:rPr>
-              <a:t>Browser :30080</a:t>
-            </a:r>
-            <a:endParaRPr lang="en-US" sz="1150" dirty="0"/>
-          </a:p>
-        </p:txBody>
-      </p:sp>
-    </p:spTree>
-  </p:cSld>
-  <p:clrMapOvr>
-    <a:masterClrMapping/>
-  </p:clrMapOvr>
-</p:sld>
-</file>
-
-<file path=ppt/slides/slide5.xml><?xml version="1.0" encoding="utf-8"?>
-<p:sld xmlns:a="http://schemas.openxmlformats.org/drawingml/2006/main" xmlns:r="http://schemas.openxmlformats.org/officeDocument/2006/relationships" xmlns:p="http://schemas.openxmlformats.org/presentationml/2006/main">
   <p:cSld name="Slide 5">
     <p:bg>
       <p:bgPr>
@@ -12771,7 +9401,7 @@
                 <a:ea typeface="Calibri" pitchFamily="34" charset="-122"/>
                 <a:cs typeface="Calibri" pitchFamily="34" charset="-120"/>
               </a:rPr>
-              <a:t>Déclaratif, état partagé, support AWS natif via provider officiel. Permet la reproductibilité complète.</a:t>
+              <a:t>support AWS natif via provider officiel. Permet la reproductibilité complète.</a:t>
             </a:r>
             <a:endParaRPr lang="en-US" sz="950" dirty="0"/>
           </a:p>
@@ -12944,7 +9574,7 @@
                 <a:ea typeface="Calibri" pitchFamily="34" charset="-122"/>
                 <a:cs typeface="Calibri" pitchFamily="34" charset="-120"/>
               </a:rPr>
-              <a:t>Sans agent, idempotent, YAML lisible. Parfait pour configurer des nœuds fraîchement provisionnés.</a:t>
+              <a:t>Sans agent, YAML lisible. Parfait pour configurer des nœuds fraîchement provisionnés.</a:t>
             </a:r>
             <a:endParaRPr lang="en-US" sz="950" dirty="0"/>
           </a:p>
@@ -13117,7 +9747,18 @@
                 <a:ea typeface="Calibri" pitchFamily="34" charset="-122"/>
                 <a:cs typeface="Calibri" pitchFamily="34" charset="-120"/>
               </a:rPr>
-              <a:t>Extensible via plugins, Jenkinsfile versionnable avec le code, intégration Docker et Kubernetes native.</a:t>
+              <a:t>Extensible </a:t>
+            </a:r>
+            <a:r>
+              <a:rPr lang="en-US" sz="950">
+                <a:solidFill>
+                  <a:srgbClr val="64748B"/>
+                </a:solidFill>
+                <a:latin typeface="Calibri" pitchFamily="34" charset="0"/>
+                <a:ea typeface="Calibri" pitchFamily="34" charset="-122"/>
+                <a:cs typeface="Calibri" pitchFamily="34" charset="-120"/>
+              </a:rPr>
+              <a:t>via plugins.</a:t>
             </a:r>
             <a:endParaRPr lang="en-US" sz="950" dirty="0"/>
           </a:p>
@@ -13290,7 +9931,51 @@
                 <a:ea typeface="Calibri" pitchFamily="34" charset="-122"/>
                 <a:cs typeface="Calibri" pitchFamily="34" charset="-120"/>
               </a:rPr>
-              <a:t>Isolation des dépendances, portabilité totale, BuildKit pour builds optimisés sur ressources limitées.</a:t>
+              <a:t>Isolation des dépendances, </a:t>
+            </a:r>
+            <a:r>
+              <a:rPr lang="en-US" sz="950" dirty="0" err="1">
+                <a:solidFill>
+                  <a:srgbClr val="64748B"/>
+                </a:solidFill>
+                <a:latin typeface="Calibri" pitchFamily="34" charset="0"/>
+                <a:ea typeface="Calibri" pitchFamily="34" charset="-122"/>
+                <a:cs typeface="Calibri" pitchFamily="34" charset="-120"/>
+              </a:rPr>
+              <a:t>portabilité</a:t>
+            </a:r>
+            <a:r>
+              <a:rPr lang="en-US" sz="950" dirty="0">
+                <a:solidFill>
+                  <a:srgbClr val="64748B"/>
+                </a:solidFill>
+                <a:latin typeface="Calibri" pitchFamily="34" charset="0"/>
+                <a:ea typeface="Calibri" pitchFamily="34" charset="-122"/>
+                <a:cs typeface="Calibri" pitchFamily="34" charset="-120"/>
+              </a:rPr>
+              <a:t> </a:t>
+            </a:r>
+            <a:r>
+              <a:rPr lang="en-US" sz="950" dirty="0" err="1">
+                <a:solidFill>
+                  <a:srgbClr val="64748B"/>
+                </a:solidFill>
+                <a:latin typeface="Calibri" pitchFamily="34" charset="0"/>
+                <a:ea typeface="Calibri" pitchFamily="34" charset="-122"/>
+                <a:cs typeface="Calibri" pitchFamily="34" charset="-120"/>
+              </a:rPr>
+              <a:t>totale</a:t>
+            </a:r>
+            <a:r>
+              <a:rPr lang="en-US" sz="950" dirty="0">
+                <a:solidFill>
+                  <a:srgbClr val="64748B"/>
+                </a:solidFill>
+                <a:latin typeface="Calibri" pitchFamily="34" charset="0"/>
+                <a:ea typeface="Calibri" pitchFamily="34" charset="-122"/>
+                <a:cs typeface="Calibri" pitchFamily="34" charset="-120"/>
+              </a:rPr>
+              <a:t>.</a:t>
             </a:r>
             <a:endParaRPr lang="en-US" sz="950" dirty="0"/>
           </a:p>
@@ -13463,7 +10148,29 @@
                 <a:ea typeface="Calibri" pitchFamily="34" charset="-122"/>
                 <a:cs typeface="Calibri" pitchFamily="34" charset="-120"/>
               </a:rPr>
-              <a:t>Distribution Kubernetes certifiée CNCF, ~70 MB RAM vs 300+ MB pour K8s. Idéal pour instances t3.micro.</a:t>
+              <a:t>Leger et </a:t>
+            </a:r>
+            <a:r>
+              <a:rPr lang="en-US" sz="950" dirty="0" err="1">
+                <a:solidFill>
+                  <a:srgbClr val="64748B"/>
+                </a:solidFill>
+                <a:latin typeface="Calibri" pitchFamily="34" charset="0"/>
+                <a:ea typeface="Calibri" pitchFamily="34" charset="-122"/>
+                <a:cs typeface="Calibri" pitchFamily="34" charset="-120"/>
+              </a:rPr>
+              <a:t>Idéal</a:t>
+            </a:r>
+            <a:r>
+              <a:rPr lang="en-US" sz="950" dirty="0">
+                <a:solidFill>
+                  <a:srgbClr val="64748B"/>
+                </a:solidFill>
+                <a:latin typeface="Calibri" pitchFamily="34" charset="0"/>
+                <a:ea typeface="Calibri" pitchFamily="34" charset="-122"/>
+                <a:cs typeface="Calibri" pitchFamily="34" charset="-120"/>
+              </a:rPr>
+              <a:t> pour instances t3.micro.</a:t>
             </a:r>
             <a:endParaRPr lang="en-US" sz="950" dirty="0"/>
           </a:p>
@@ -13649,9 +10356,17 @@
           <a:bodyPr wrap="square" lIns="0" tIns="0" rIns="0" bIns="0" rtlCol="0" anchor="ctr"/>
           <a:lstStyle/>
           <a:p>
-            <a:pPr marL="0" indent="0">
-              <a:buNone/>
-            </a:pPr>
+            <a:r>
+              <a:rPr lang="en-US" sz="950" dirty="0" err="1">
+                <a:solidFill>
+                  <a:srgbClr val="64748B"/>
+                </a:solidFill>
+                <a:latin typeface="Calibri" pitchFamily="34" charset="0"/>
+                <a:ea typeface="Calibri" pitchFamily="34" charset="-122"/>
+                <a:cs typeface="Calibri" pitchFamily="34" charset="-120"/>
+              </a:rPr>
+              <a:t>Stabilté</a:t>
+            </a:r>
             <a:r>
               <a:rPr lang="en-US" sz="950" dirty="0">
                 <a:solidFill>
@@ -13661,7 +10376,51 @@
                 <a:ea typeface="Calibri" pitchFamily="34" charset="-122"/>
                 <a:cs typeface="Calibri" pitchFamily="34" charset="-120"/>
               </a:rPr>
-              <a:t>t3.micro avec Debian 12 : stabilité, coût maîtrisé, VPC et Security Groups pour l'isolation réseau.</a:t>
+              <a:t> et </a:t>
+            </a:r>
+            <a:r>
+              <a:rPr lang="en-US" sz="950" dirty="0" err="1">
+                <a:solidFill>
+                  <a:srgbClr val="64748B"/>
+                </a:solidFill>
+                <a:latin typeface="Calibri" pitchFamily="34" charset="0"/>
+                <a:ea typeface="Calibri" pitchFamily="34" charset="-122"/>
+                <a:cs typeface="Calibri" pitchFamily="34" charset="-120"/>
+              </a:rPr>
+              <a:t>securité</a:t>
+            </a:r>
+            <a:r>
+              <a:rPr lang="en-US" sz="950" dirty="0">
+                <a:solidFill>
+                  <a:srgbClr val="64748B"/>
+                </a:solidFill>
+                <a:latin typeface="Calibri" pitchFamily="34" charset="0"/>
+                <a:ea typeface="Calibri" pitchFamily="34" charset="-122"/>
+                <a:cs typeface="Calibri" pitchFamily="34" charset="-120"/>
+              </a:rPr>
+              <a:t> </a:t>
+            </a:r>
+            <a:r>
+              <a:rPr lang="en-US" sz="950" dirty="0" err="1">
+                <a:solidFill>
+                  <a:srgbClr val="64748B"/>
+                </a:solidFill>
+                <a:latin typeface="Calibri" pitchFamily="34" charset="0"/>
+                <a:ea typeface="Calibri" pitchFamily="34" charset="-122"/>
+                <a:cs typeface="Calibri" pitchFamily="34" charset="-120"/>
+              </a:rPr>
+              <a:t>élevée</a:t>
+            </a:r>
+            <a:r>
+              <a:rPr lang="en-US" sz="950" dirty="0">
+                <a:solidFill>
+                  <a:srgbClr val="64748B"/>
+                </a:solidFill>
+                <a:latin typeface="Calibri" pitchFamily="34" charset="0"/>
+                <a:ea typeface="Calibri" pitchFamily="34" charset="-122"/>
+                <a:cs typeface="Calibri" pitchFamily="34" charset="-120"/>
+              </a:rPr>
+              <a:t>.</a:t>
             </a:r>
             <a:endParaRPr lang="en-US" sz="950" dirty="0"/>
           </a:p>
@@ -13675,7 +10434,7 @@
 </p:sld>
 </file>
 
-<file path=ppt/slides/slide6.xml><?xml version="1.0" encoding="utf-8"?>
+<file path=ppt/slides/slide5.xml><?xml version="1.0" encoding="utf-8"?>
 <p:sld xmlns:a="http://schemas.openxmlformats.org/drawingml/2006/main" xmlns:r="http://schemas.openxmlformats.org/officeDocument/2006/relationships" xmlns:p="http://schemas.openxmlformats.org/presentationml/2006/main">
   <p:cSld name="Slide 6">
     <p:bg>
@@ -15383,7 +12142,7 @@
 </p:sld>
 </file>
 
-<file path=ppt/slides/slide7.xml><?xml version="1.0" encoding="utf-8"?>
+<file path=ppt/slides/slide6.xml><?xml version="1.0" encoding="utf-8"?>
 <p:sld xmlns:a="http://schemas.openxmlformats.org/drawingml/2006/main" xmlns:r="http://schemas.openxmlformats.org/officeDocument/2006/relationships" xmlns:p="http://schemas.openxmlformats.org/presentationml/2006/main">
   <p:cSld name="Slide 7">
     <p:bg>
@@ -16334,7 +13093,7 @@
 </p:sld>
 </file>
 
-<file path=ppt/slides/slide8.xml><?xml version="1.0" encoding="utf-8"?>
+<file path=ppt/slides/slide7.xml><?xml version="1.0" encoding="utf-8"?>
 <p:sld xmlns:a="http://schemas.openxmlformats.org/drawingml/2006/main" xmlns:r="http://schemas.openxmlformats.org/officeDocument/2006/relationships" xmlns:p="http://schemas.openxmlformats.org/presentationml/2006/main">
   <p:cSld name="Slide 8">
     <p:bg>
@@ -17792,7 +14551,7 @@
 </p:sld>
 </file>
 
-<file path=ppt/slides/slide9.xml><?xml version="1.0" encoding="utf-8"?>
+<file path=ppt/slides/slide8.xml><?xml version="1.0" encoding="utf-8"?>
 <p:sld xmlns:a="http://schemas.openxmlformats.org/drawingml/2006/main" xmlns:r="http://schemas.openxmlformats.org/officeDocument/2006/relationships" xmlns:p="http://schemas.openxmlformats.org/presentationml/2006/main">
   <p:cSld name="Slide 9">
     <p:bg>
@@ -19456,6 +16215,1146 @@
                 <a:cs typeface="Calibri" pitchFamily="34" charset="-120"/>
               </a:rPr>
               <a:t>NodePort 30080 expose l'app · image prune</a:t>
+            </a:r>
+            <a:endParaRPr lang="en-US" sz="1000" dirty="0"/>
+          </a:p>
+        </p:txBody>
+      </p:sp>
+    </p:spTree>
+  </p:cSld>
+  <p:clrMapOvr>
+    <a:masterClrMapping/>
+  </p:clrMapOvr>
+</p:sld>
+</file>
+
+<file path=ppt/slides/slide9.xml><?xml version="1.0" encoding="utf-8"?>
+<p:sld xmlns:a="http://schemas.openxmlformats.org/drawingml/2006/main" xmlns:r="http://schemas.openxmlformats.org/officeDocument/2006/relationships" xmlns:p="http://schemas.openxmlformats.org/presentationml/2006/main">
+  <p:cSld name="Slide 10">
+    <p:bg>
+      <p:bgPr>
+        <a:solidFill>
+          <a:srgbClr val="F4F8FC"/>
+        </a:solidFill>
+        <a:effectLst/>
+      </p:bgPr>
+    </p:bg>
+    <p:spTree>
+      <p:nvGrpSpPr>
+        <p:cNvPr id="1" name=""/>
+        <p:cNvGrpSpPr/>
+        <p:nvPr/>
+      </p:nvGrpSpPr>
+      <p:grpSpPr>
+        <a:xfrm>
+          <a:off x="0" y="0"/>
+          <a:ext cx="0" cy="0"/>
+          <a:chOff x="0" y="0"/>
+          <a:chExt cx="0" cy="0"/>
+        </a:xfrm>
+      </p:grpSpPr>
+      <p:sp>
+        <p:nvSpPr>
+          <p:cNvPr id="2" name="Shape 0"/>
+          <p:cNvSpPr/>
+          <p:nvPr/>
+        </p:nvSpPr>
+        <p:spPr>
+          <a:xfrm>
+            <a:off x="0" y="0"/>
+            <a:ext cx="9144000" cy="1005840"/>
+          </a:xfrm>
+          <a:prstGeom prst="rect">
+            <a:avLst/>
+          </a:prstGeom>
+          <a:solidFill>
+            <a:srgbClr val="0D1B2A"/>
+          </a:solidFill>
+          <a:ln w="12700">
+            <a:solidFill>
+              <a:srgbClr val="0D1B2A"/>
+            </a:solidFill>
+            <a:prstDash val="solid"/>
+          </a:ln>
+        </p:spPr>
+      </p:sp>
+      <p:sp>
+        <p:nvSpPr>
+          <p:cNvPr id="3" name="Shape 1"/>
+          <p:cNvSpPr/>
+          <p:nvPr/>
+        </p:nvSpPr>
+        <p:spPr>
+          <a:xfrm>
+            <a:off x="0" y="960120"/>
+            <a:ext cx="9144000" cy="45720"/>
+          </a:xfrm>
+          <a:prstGeom prst="rect">
+            <a:avLst/>
+          </a:prstGeom>
+          <a:solidFill>
+            <a:srgbClr val="2196F3"/>
+          </a:solidFill>
+          <a:ln w="12700">
+            <a:solidFill>
+              <a:srgbClr val="2196F3"/>
+            </a:solidFill>
+            <a:prstDash val="solid"/>
+          </a:ln>
+        </p:spPr>
+      </p:sp>
+      <p:sp>
+        <p:nvSpPr>
+          <p:cNvPr id="4" name="Text 2"/>
+          <p:cNvSpPr/>
+          <p:nvPr/>
+        </p:nvSpPr>
+        <p:spPr>
+          <a:xfrm>
+            <a:off x="411480" y="109728"/>
+            <a:ext cx="7315200" cy="548640"/>
+          </a:xfrm>
+          <a:prstGeom prst="rect">
+            <a:avLst/>
+          </a:prstGeom>
+          <a:noFill/>
+          <a:ln/>
+        </p:spPr>
+        <p:txBody>
+          <a:bodyPr wrap="square" lIns="0" tIns="0" rIns="0" bIns="0" rtlCol="0" anchor="ctr"/>
+          <a:lstStyle/>
+          <a:p>
+            <a:pPr marL="0" indent="0">
+              <a:buNone/>
+            </a:pPr>
+            <a:r>
+              <a:rPr lang="en-US" sz="2600" b="1" dirty="0">
+                <a:solidFill>
+                  <a:srgbClr val="FFFFFF"/>
+                </a:solidFill>
+                <a:latin typeface="Calibri" pitchFamily="34" charset="0"/>
+                <a:ea typeface="Calibri" pitchFamily="34" charset="-122"/>
+                <a:cs typeface="Calibri" pitchFamily="34" charset="-120"/>
+              </a:rPr>
+              <a:t>06 · Orchestration — Cluster K3s</a:t>
+            </a:r>
+            <a:endParaRPr lang="en-US" sz="2600" dirty="0"/>
+          </a:p>
+        </p:txBody>
+      </p:sp>
+      <p:sp>
+        <p:nvSpPr>
+          <p:cNvPr id="5" name="Text 3"/>
+          <p:cNvSpPr/>
+          <p:nvPr/>
+        </p:nvSpPr>
+        <p:spPr>
+          <a:xfrm>
+            <a:off x="411480" y="594360"/>
+            <a:ext cx="7315200" cy="347472"/>
+          </a:xfrm>
+          <a:prstGeom prst="rect">
+            <a:avLst/>
+          </a:prstGeom>
+          <a:noFill/>
+          <a:ln/>
+        </p:spPr>
+        <p:txBody>
+          <a:bodyPr wrap="square" lIns="0" tIns="0" rIns="0" bIns="0" rtlCol="0" anchor="ctr"/>
+          <a:lstStyle/>
+          <a:p>
+            <a:pPr marL="0" indent="0">
+              <a:buNone/>
+            </a:pPr>
+            <a:r>
+              <a:rPr lang="en-US" sz="1300" i="1" dirty="0">
+                <a:solidFill>
+                  <a:srgbClr val="90CAF9"/>
+                </a:solidFill>
+                <a:latin typeface="Calibri" pitchFamily="34" charset="0"/>
+                <a:ea typeface="Calibri" pitchFamily="34" charset="-122"/>
+                <a:cs typeface="Calibri" pitchFamily="34" charset="-120"/>
+              </a:rPr>
+              <a:t>Déploiement Kubernetes léger : Master + Worker, pods et exposition NodePort</a:t>
+            </a:r>
+            <a:endParaRPr lang="en-US" sz="1300" dirty="0"/>
+          </a:p>
+        </p:txBody>
+      </p:sp>
+      <p:sp>
+        <p:nvSpPr>
+          <p:cNvPr id="6" name="Shape 4"/>
+          <p:cNvSpPr/>
+          <p:nvPr/>
+        </p:nvSpPr>
+        <p:spPr>
+          <a:xfrm>
+            <a:off x="320040" y="1188720"/>
+            <a:ext cx="5029200" cy="749808"/>
+          </a:xfrm>
+          <a:prstGeom prst="rect">
+            <a:avLst/>
+          </a:prstGeom>
+          <a:solidFill>
+            <a:srgbClr val="FFFFFF"/>
+          </a:solidFill>
+          <a:ln w="12700">
+            <a:solidFill>
+              <a:srgbClr val="BFDBFE"/>
+            </a:solidFill>
+            <a:prstDash val="solid"/>
+          </a:ln>
+          <a:effectLst>
+            <a:outerShdw blurRad="101600" dist="25400" dir="8100000" algn="bl" rotWithShape="0">
+              <a:srgbClr val="000000">
+                <a:alpha val="10000"/>
+              </a:srgbClr>
+            </a:outerShdw>
+          </a:effectLst>
+        </p:spPr>
+      </p:sp>
+      <p:sp>
+        <p:nvSpPr>
+          <p:cNvPr id="7" name="Shape 5"/>
+          <p:cNvSpPr/>
+          <p:nvPr/>
+        </p:nvSpPr>
+        <p:spPr>
+          <a:xfrm>
+            <a:off x="320040" y="1188720"/>
+            <a:ext cx="64008" cy="749808"/>
+          </a:xfrm>
+          <a:prstGeom prst="rect">
+            <a:avLst/>
+          </a:prstGeom>
+          <a:solidFill>
+            <a:srgbClr val="326CE5"/>
+          </a:solidFill>
+          <a:ln w="12700">
+            <a:solidFill>
+              <a:srgbClr val="326CE5"/>
+            </a:solidFill>
+            <a:prstDash val="solid"/>
+          </a:ln>
+        </p:spPr>
+      </p:sp>
+      <p:sp>
+        <p:nvSpPr>
+          <p:cNvPr id="8" name="Text 6"/>
+          <p:cNvSpPr/>
+          <p:nvPr/>
+        </p:nvSpPr>
+        <p:spPr>
+          <a:xfrm>
+            <a:off x="548640" y="1234440"/>
+            <a:ext cx="4663440" cy="274320"/>
+          </a:xfrm>
+          <a:prstGeom prst="rect">
+            <a:avLst/>
+          </a:prstGeom>
+          <a:noFill/>
+          <a:ln/>
+        </p:spPr>
+        <p:txBody>
+          <a:bodyPr wrap="square" lIns="0" tIns="0" rIns="0" bIns="0" rtlCol="0" anchor="ctr"/>
+          <a:lstStyle/>
+          <a:p>
+            <a:pPr marL="0" indent="0">
+              <a:buNone/>
+            </a:pPr>
+            <a:r>
+              <a:rPr lang="en-US" sz="1250" b="1" dirty="0">
+                <a:solidFill>
+                  <a:srgbClr val="1E293B"/>
+                </a:solidFill>
+                <a:latin typeface="Calibri" pitchFamily="34" charset="0"/>
+                <a:ea typeface="Calibri" pitchFamily="34" charset="-122"/>
+                <a:cs typeface="Calibri" pitchFamily="34" charset="-120"/>
+              </a:rPr>
+              <a:t>Deployment : portfolio-deploy</a:t>
+            </a:r>
+            <a:endParaRPr lang="en-US" sz="1250" dirty="0"/>
+          </a:p>
+        </p:txBody>
+      </p:sp>
+      <p:sp>
+        <p:nvSpPr>
+          <p:cNvPr id="9" name="Text 7"/>
+          <p:cNvSpPr/>
+          <p:nvPr/>
+        </p:nvSpPr>
+        <p:spPr>
+          <a:xfrm>
+            <a:off x="548640" y="1517904"/>
+            <a:ext cx="4663440" cy="274320"/>
+          </a:xfrm>
+          <a:prstGeom prst="rect">
+            <a:avLst/>
+          </a:prstGeom>
+          <a:noFill/>
+          <a:ln/>
+        </p:spPr>
+        <p:txBody>
+          <a:bodyPr wrap="square" lIns="0" tIns="0" rIns="0" bIns="0" rtlCol="0" anchor="ctr"/>
+          <a:lstStyle/>
+          <a:p>
+            <a:pPr marL="0" indent="0">
+              <a:buNone/>
+            </a:pPr>
+            <a:r>
+              <a:rPr lang="en-US" sz="1050" dirty="0">
+                <a:solidFill>
+                  <a:srgbClr val="64748B"/>
+                </a:solidFill>
+                <a:latin typeface="Calibri" pitchFamily="34" charset="0"/>
+                <a:ea typeface="Calibri" pitchFamily="34" charset="-122"/>
+                <a:cs typeface="Calibri" pitchFamily="34" charset="-120"/>
+              </a:rPr>
+              <a:t>Manifeste Kubernetes géré par Jenkins via kubectl apply</a:t>
+            </a:r>
+            <a:endParaRPr lang="en-US" sz="1050" dirty="0"/>
+          </a:p>
+        </p:txBody>
+      </p:sp>
+      <p:sp>
+        <p:nvSpPr>
+          <p:cNvPr id="10" name="Shape 8"/>
+          <p:cNvSpPr/>
+          <p:nvPr/>
+        </p:nvSpPr>
+        <p:spPr>
+          <a:xfrm>
+            <a:off x="320040" y="2084832"/>
+            <a:ext cx="5029200" cy="749808"/>
+          </a:xfrm>
+          <a:prstGeom prst="rect">
+            <a:avLst/>
+          </a:prstGeom>
+          <a:solidFill>
+            <a:srgbClr val="FFFFFF"/>
+          </a:solidFill>
+          <a:ln w="12700">
+            <a:solidFill>
+              <a:srgbClr val="BFDBFE"/>
+            </a:solidFill>
+            <a:prstDash val="solid"/>
+          </a:ln>
+          <a:effectLst>
+            <a:outerShdw blurRad="101600" dist="25400" dir="8100000" algn="bl" rotWithShape="0">
+              <a:srgbClr val="000000">
+                <a:alpha val="10000"/>
+              </a:srgbClr>
+            </a:outerShdw>
+          </a:effectLst>
+        </p:spPr>
+      </p:sp>
+      <p:sp>
+        <p:nvSpPr>
+          <p:cNvPr id="11" name="Shape 9"/>
+          <p:cNvSpPr/>
+          <p:nvPr/>
+        </p:nvSpPr>
+        <p:spPr>
+          <a:xfrm>
+            <a:off x="320040" y="2084832"/>
+            <a:ext cx="64008" cy="749808"/>
+          </a:xfrm>
+          <a:prstGeom prst="rect">
+            <a:avLst/>
+          </a:prstGeom>
+          <a:solidFill>
+            <a:srgbClr val="2196F3"/>
+          </a:solidFill>
+          <a:ln w="12700">
+            <a:solidFill>
+              <a:srgbClr val="2196F3"/>
+            </a:solidFill>
+            <a:prstDash val="solid"/>
+          </a:ln>
+        </p:spPr>
+      </p:sp>
+      <p:sp>
+        <p:nvSpPr>
+          <p:cNvPr id="12" name="Text 10"/>
+          <p:cNvSpPr/>
+          <p:nvPr/>
+        </p:nvSpPr>
+        <p:spPr>
+          <a:xfrm>
+            <a:off x="548640" y="2130552"/>
+            <a:ext cx="4663440" cy="274320"/>
+          </a:xfrm>
+          <a:prstGeom prst="rect">
+            <a:avLst/>
+          </a:prstGeom>
+          <a:noFill/>
+          <a:ln/>
+        </p:spPr>
+        <p:txBody>
+          <a:bodyPr wrap="square" lIns="0" tIns="0" rIns="0" bIns="0" rtlCol="0" anchor="ctr"/>
+          <a:lstStyle/>
+          <a:p>
+            <a:pPr marL="0" indent="0">
+              <a:buNone/>
+            </a:pPr>
+            <a:r>
+              <a:rPr lang="en-US" sz="1250" b="1" dirty="0">
+                <a:solidFill>
+                  <a:srgbClr val="1E293B"/>
+                </a:solidFill>
+                <a:latin typeface="Calibri" pitchFamily="34" charset="0"/>
+                <a:ea typeface="Calibri" pitchFamily="34" charset="-122"/>
+                <a:cs typeface="Calibri" pitchFamily="34" charset="-120"/>
+              </a:rPr>
+              <a:t>Pod : portfolio-container</a:t>
+            </a:r>
+            <a:endParaRPr lang="en-US" sz="1250" dirty="0"/>
+          </a:p>
+        </p:txBody>
+      </p:sp>
+      <p:sp>
+        <p:nvSpPr>
+          <p:cNvPr id="13" name="Text 11"/>
+          <p:cNvSpPr/>
+          <p:nvPr/>
+        </p:nvSpPr>
+        <p:spPr>
+          <a:xfrm>
+            <a:off x="548640" y="2414016"/>
+            <a:ext cx="4663440" cy="274320"/>
+          </a:xfrm>
+          <a:prstGeom prst="rect">
+            <a:avLst/>
+          </a:prstGeom>
+          <a:noFill/>
+          <a:ln/>
+        </p:spPr>
+        <p:txBody>
+          <a:bodyPr wrap="square" lIns="0" tIns="0" rIns="0" bIns="0" rtlCol="0" anchor="ctr"/>
+          <a:lstStyle/>
+          <a:p>
+            <a:pPr marL="0" indent="0">
+              <a:buNone/>
+            </a:pPr>
+            <a:r>
+              <a:rPr lang="en-US" sz="1050" dirty="0">
+                <a:solidFill>
+                  <a:srgbClr val="64748B"/>
+                </a:solidFill>
+                <a:latin typeface="Calibri" pitchFamily="34" charset="0"/>
+                <a:ea typeface="Calibri" pitchFamily="34" charset="-122"/>
+                <a:cs typeface="Calibri" pitchFamily="34" charset="-120"/>
+              </a:rPr>
+              <a:t>Image Docker versionnée depuis Docker Hub (:$BUILD_NUMBER)</a:t>
+            </a:r>
+            <a:endParaRPr lang="en-US" sz="1050" dirty="0"/>
+          </a:p>
+        </p:txBody>
+      </p:sp>
+      <p:sp>
+        <p:nvSpPr>
+          <p:cNvPr id="14" name="Shape 12"/>
+          <p:cNvSpPr/>
+          <p:nvPr/>
+        </p:nvSpPr>
+        <p:spPr>
+          <a:xfrm>
+            <a:off x="320040" y="2980944"/>
+            <a:ext cx="5029200" cy="749808"/>
+          </a:xfrm>
+          <a:prstGeom prst="rect">
+            <a:avLst/>
+          </a:prstGeom>
+          <a:solidFill>
+            <a:srgbClr val="FFFFFF"/>
+          </a:solidFill>
+          <a:ln w="12700">
+            <a:solidFill>
+              <a:srgbClr val="BFDBFE"/>
+            </a:solidFill>
+            <a:prstDash val="solid"/>
+          </a:ln>
+          <a:effectLst>
+            <a:outerShdw blurRad="101600" dist="25400" dir="8100000" algn="bl" rotWithShape="0">
+              <a:srgbClr val="000000">
+                <a:alpha val="10000"/>
+              </a:srgbClr>
+            </a:outerShdw>
+          </a:effectLst>
+        </p:spPr>
+      </p:sp>
+      <p:sp>
+        <p:nvSpPr>
+          <p:cNvPr id="15" name="Shape 13"/>
+          <p:cNvSpPr/>
+          <p:nvPr/>
+        </p:nvSpPr>
+        <p:spPr>
+          <a:xfrm>
+            <a:off x="320040" y="2980944"/>
+            <a:ext cx="64008" cy="749808"/>
+          </a:xfrm>
+          <a:prstGeom prst="rect">
+            <a:avLst/>
+          </a:prstGeom>
+          <a:solidFill>
+            <a:srgbClr val="00BCD4"/>
+          </a:solidFill>
+          <a:ln w="12700">
+            <a:solidFill>
+              <a:srgbClr val="00BCD4"/>
+            </a:solidFill>
+            <a:prstDash val="solid"/>
+          </a:ln>
+        </p:spPr>
+      </p:sp>
+      <p:sp>
+        <p:nvSpPr>
+          <p:cNvPr id="16" name="Text 14"/>
+          <p:cNvSpPr/>
+          <p:nvPr/>
+        </p:nvSpPr>
+        <p:spPr>
+          <a:xfrm>
+            <a:off x="548640" y="3026664"/>
+            <a:ext cx="4663440" cy="274320"/>
+          </a:xfrm>
+          <a:prstGeom prst="rect">
+            <a:avLst/>
+          </a:prstGeom>
+          <a:noFill/>
+          <a:ln/>
+        </p:spPr>
+        <p:txBody>
+          <a:bodyPr wrap="square" lIns="0" tIns="0" rIns="0" bIns="0" rtlCol="0" anchor="ctr"/>
+          <a:lstStyle/>
+          <a:p>
+            <a:pPr marL="0" indent="0">
+              <a:buNone/>
+            </a:pPr>
+            <a:r>
+              <a:rPr lang="en-US" sz="1250" b="1" dirty="0">
+                <a:solidFill>
+                  <a:srgbClr val="1E293B"/>
+                </a:solidFill>
+                <a:latin typeface="Calibri" pitchFamily="34" charset="0"/>
+                <a:ea typeface="Calibri" pitchFamily="34" charset="-122"/>
+                <a:cs typeface="Calibri" pitchFamily="34" charset="-120"/>
+              </a:rPr>
+              <a:t>Service : NodePort 30080</a:t>
+            </a:r>
+            <a:endParaRPr lang="en-US" sz="1250" dirty="0"/>
+          </a:p>
+        </p:txBody>
+      </p:sp>
+      <p:sp>
+        <p:nvSpPr>
+          <p:cNvPr id="17" name="Text 15"/>
+          <p:cNvSpPr/>
+          <p:nvPr/>
+        </p:nvSpPr>
+        <p:spPr>
+          <a:xfrm>
+            <a:off x="548640" y="3310128"/>
+            <a:ext cx="4663440" cy="274320"/>
+          </a:xfrm>
+          <a:prstGeom prst="rect">
+            <a:avLst/>
+          </a:prstGeom>
+          <a:noFill/>
+          <a:ln/>
+        </p:spPr>
+        <p:txBody>
+          <a:bodyPr wrap="square" lIns="0" tIns="0" rIns="0" bIns="0" rtlCol="0" anchor="ctr"/>
+          <a:lstStyle/>
+          <a:p>
+            <a:pPr marL="0" indent="0">
+              <a:buNone/>
+            </a:pPr>
+            <a:r>
+              <a:rPr lang="en-US" sz="1050" dirty="0">
+                <a:solidFill>
+                  <a:srgbClr val="64748B"/>
+                </a:solidFill>
+                <a:latin typeface="Calibri" pitchFamily="34" charset="0"/>
+                <a:ea typeface="Calibri" pitchFamily="34" charset="-122"/>
+                <a:cs typeface="Calibri" pitchFamily="34" charset="-120"/>
+              </a:rPr>
+              <a:t>Expose publiquement l'application sur worker-ip:30080</a:t>
+            </a:r>
+            <a:endParaRPr lang="en-US" sz="1050" dirty="0"/>
+          </a:p>
+        </p:txBody>
+      </p:sp>
+      <p:sp>
+        <p:nvSpPr>
+          <p:cNvPr id="18" name="Shape 16"/>
+          <p:cNvSpPr/>
+          <p:nvPr/>
+        </p:nvSpPr>
+        <p:spPr>
+          <a:xfrm>
+            <a:off x="320040" y="3877056"/>
+            <a:ext cx="5029200" cy="749808"/>
+          </a:xfrm>
+          <a:prstGeom prst="rect">
+            <a:avLst/>
+          </a:prstGeom>
+          <a:solidFill>
+            <a:srgbClr val="FFFFFF"/>
+          </a:solidFill>
+          <a:ln w="12700">
+            <a:solidFill>
+              <a:srgbClr val="BFDBFE"/>
+            </a:solidFill>
+            <a:prstDash val="solid"/>
+          </a:ln>
+          <a:effectLst>
+            <a:outerShdw blurRad="101600" dist="25400" dir="8100000" algn="bl" rotWithShape="0">
+              <a:srgbClr val="000000">
+                <a:alpha val="10000"/>
+              </a:srgbClr>
+            </a:outerShdw>
+          </a:effectLst>
+        </p:spPr>
+      </p:sp>
+      <p:sp>
+        <p:nvSpPr>
+          <p:cNvPr id="19" name="Shape 17"/>
+          <p:cNvSpPr/>
+          <p:nvPr/>
+        </p:nvSpPr>
+        <p:spPr>
+          <a:xfrm>
+            <a:off x="320040" y="3877056"/>
+            <a:ext cx="64008" cy="749808"/>
+          </a:xfrm>
+          <a:prstGeom prst="rect">
+            <a:avLst/>
+          </a:prstGeom>
+          <a:solidFill>
+            <a:srgbClr val="10B981"/>
+          </a:solidFill>
+          <a:ln w="12700">
+            <a:solidFill>
+              <a:srgbClr val="10B981"/>
+            </a:solidFill>
+            <a:prstDash val="solid"/>
+          </a:ln>
+        </p:spPr>
+      </p:sp>
+      <p:sp>
+        <p:nvSpPr>
+          <p:cNvPr id="20" name="Text 18"/>
+          <p:cNvSpPr/>
+          <p:nvPr/>
+        </p:nvSpPr>
+        <p:spPr>
+          <a:xfrm>
+            <a:off x="548640" y="3922776"/>
+            <a:ext cx="4663440" cy="274320"/>
+          </a:xfrm>
+          <a:prstGeom prst="rect">
+            <a:avLst/>
+          </a:prstGeom>
+          <a:noFill/>
+          <a:ln/>
+        </p:spPr>
+        <p:txBody>
+          <a:bodyPr wrap="square" lIns="0" tIns="0" rIns="0" bIns="0" rtlCol="0" anchor="ctr"/>
+          <a:lstStyle/>
+          <a:p>
+            <a:pPr marL="0" indent="0">
+              <a:buNone/>
+            </a:pPr>
+            <a:r>
+              <a:rPr lang="en-US" sz="1250" b="1" dirty="0">
+                <a:solidFill>
+                  <a:srgbClr val="1E293B"/>
+                </a:solidFill>
+                <a:latin typeface="Calibri" pitchFamily="34" charset="0"/>
+                <a:ea typeface="Calibri" pitchFamily="34" charset="-122"/>
+                <a:cs typeface="Calibri" pitchFamily="34" charset="-120"/>
+              </a:rPr>
+              <a:t>Ressources limitées</a:t>
+            </a:r>
+            <a:endParaRPr lang="en-US" sz="1250" dirty="0"/>
+          </a:p>
+        </p:txBody>
+      </p:sp>
+      <p:sp>
+        <p:nvSpPr>
+          <p:cNvPr id="21" name="Text 19"/>
+          <p:cNvSpPr/>
+          <p:nvPr/>
+        </p:nvSpPr>
+        <p:spPr>
+          <a:xfrm>
+            <a:off x="548640" y="4206240"/>
+            <a:ext cx="4663440" cy="274320"/>
+          </a:xfrm>
+          <a:prstGeom prst="rect">
+            <a:avLst/>
+          </a:prstGeom>
+          <a:noFill/>
+          <a:ln/>
+        </p:spPr>
+        <p:txBody>
+          <a:bodyPr wrap="square" lIns="0" tIns="0" rIns="0" bIns="0" rtlCol="0" anchor="ctr"/>
+          <a:lstStyle/>
+          <a:p>
+            <a:pPr marL="0" indent="0">
+              <a:buNone/>
+            </a:pPr>
+            <a:r>
+              <a:rPr lang="en-US" sz="1050" dirty="0">
+                <a:solidFill>
+                  <a:srgbClr val="64748B"/>
+                </a:solidFill>
+                <a:latin typeface="Calibri" pitchFamily="34" charset="0"/>
+                <a:ea typeface="Calibri" pitchFamily="34" charset="-122"/>
+                <a:cs typeface="Calibri" pitchFamily="34" charset="-120"/>
+              </a:rPr>
+              <a:t>256Mi RAM · 250m CPU par pod — optimisé pour t3.micro</a:t>
+            </a:r>
+            <a:endParaRPr lang="en-US" sz="1050" dirty="0"/>
+          </a:p>
+        </p:txBody>
+      </p:sp>
+      <p:sp>
+        <p:nvSpPr>
+          <p:cNvPr id="22" name="Shape 20"/>
+          <p:cNvSpPr/>
+          <p:nvPr/>
+        </p:nvSpPr>
+        <p:spPr>
+          <a:xfrm>
+            <a:off x="5623560" y="1097280"/>
+            <a:ext cx="3200400" cy="3749040"/>
+          </a:xfrm>
+          <a:prstGeom prst="rect">
+            <a:avLst/>
+          </a:prstGeom>
+          <a:solidFill>
+            <a:srgbClr val="EFF6FF"/>
+          </a:solidFill>
+          <a:ln w="12700">
+            <a:solidFill>
+              <a:srgbClr val="BFDBFE"/>
+            </a:solidFill>
+            <a:prstDash val="solid"/>
+          </a:ln>
+          <a:effectLst>
+            <a:outerShdw blurRad="101600" dist="25400" dir="8100000" algn="bl" rotWithShape="0">
+              <a:srgbClr val="000000">
+                <a:alpha val="10000"/>
+              </a:srgbClr>
+            </a:outerShdw>
+          </a:effectLst>
+        </p:spPr>
+      </p:sp>
+      <p:sp>
+        <p:nvSpPr>
+          <p:cNvPr id="23" name="Text 21"/>
+          <p:cNvSpPr/>
+          <p:nvPr/>
+        </p:nvSpPr>
+        <p:spPr>
+          <a:xfrm>
+            <a:off x="5760720" y="1170432"/>
+            <a:ext cx="2926080" cy="320040"/>
+          </a:xfrm>
+          <a:prstGeom prst="rect">
+            <a:avLst/>
+          </a:prstGeom>
+          <a:noFill/>
+          <a:ln/>
+        </p:spPr>
+        <p:txBody>
+          <a:bodyPr wrap="square" rtlCol="0" anchor="ctr"/>
+          <a:lstStyle/>
+          <a:p>
+            <a:pPr marL="0" indent="0" algn="ctr">
+              <a:buNone/>
+            </a:pPr>
+            <a:r>
+              <a:rPr lang="en-US" sz="1300" b="1" dirty="0">
+                <a:solidFill>
+                  <a:srgbClr val="0D1B2A"/>
+                </a:solidFill>
+                <a:latin typeface="Calibri" pitchFamily="34" charset="0"/>
+                <a:ea typeface="Calibri" pitchFamily="34" charset="-122"/>
+                <a:cs typeface="Calibri" pitchFamily="34" charset="-120"/>
+              </a:rPr>
+              <a:t>Architecture K3s</a:t>
+            </a:r>
+            <a:endParaRPr lang="en-US" sz="1300" dirty="0"/>
+          </a:p>
+        </p:txBody>
+      </p:sp>
+      <p:sp>
+        <p:nvSpPr>
+          <p:cNvPr id="24" name="Shape 22"/>
+          <p:cNvSpPr/>
+          <p:nvPr/>
+        </p:nvSpPr>
+        <p:spPr>
+          <a:xfrm>
+            <a:off x="5943600" y="1600200"/>
+            <a:ext cx="2743200" cy="685800"/>
+          </a:xfrm>
+          <a:prstGeom prst="rect">
+            <a:avLst/>
+          </a:prstGeom>
+          <a:solidFill>
+            <a:srgbClr val="326CE5"/>
+          </a:solidFill>
+          <a:ln w="12700">
+            <a:solidFill>
+              <a:srgbClr val="326CE5"/>
+            </a:solidFill>
+            <a:prstDash val="solid"/>
+          </a:ln>
+          <a:effectLst>
+            <a:outerShdw blurRad="101600" dist="25400" dir="8100000" algn="bl" rotWithShape="0">
+              <a:srgbClr val="000000">
+                <a:alpha val="10000"/>
+              </a:srgbClr>
+            </a:outerShdw>
+          </a:effectLst>
+        </p:spPr>
+      </p:sp>
+      <p:pic>
+        <p:nvPicPr>
+          <p:cNvPr id="25" name="Image 0"/>
+          <p:cNvPicPr>
+            <a:picLocks noChangeAspect="1"/>
+          </p:cNvPicPr>
+          <p:nvPr/>
+        </p:nvPicPr>
+        <p:blipFill>
+          <a:blip r:embed="rId3"/>
+          <a:srcRect/>
+          <a:stretch/>
+        </p:blipFill>
+        <p:spPr>
+          <a:xfrm>
+            <a:off x="5989320" y="1664208"/>
+            <a:ext cx="457200" cy="457200"/>
+          </a:xfrm>
+          <a:prstGeom prst="rect">
+            <a:avLst/>
+          </a:prstGeom>
+          <a:noFill/>
+        </p:spPr>
+      </p:pic>
+      <p:sp>
+        <p:nvSpPr>
+          <p:cNvPr id="26" name="Text 23"/>
+          <p:cNvSpPr/>
+          <p:nvPr/>
+        </p:nvSpPr>
+        <p:spPr>
+          <a:xfrm>
+            <a:off x="6492240" y="1645920"/>
+            <a:ext cx="2103120" cy="548640"/>
+          </a:xfrm>
+          <a:prstGeom prst="rect">
+            <a:avLst/>
+          </a:prstGeom>
+          <a:noFill/>
+          <a:ln/>
+        </p:spPr>
+        <p:txBody>
+          <a:bodyPr wrap="square" lIns="0" tIns="0" rIns="0" bIns="0" rtlCol="0" anchor="ctr"/>
+          <a:lstStyle/>
+          <a:p>
+            <a:pPr marL="0" indent="0">
+              <a:buNone/>
+            </a:pPr>
+            <a:r>
+              <a:rPr lang="en-US" sz="1000" dirty="0">
+                <a:solidFill>
+                  <a:srgbClr val="FFFFFF"/>
+                </a:solidFill>
+                <a:latin typeface="Calibri" pitchFamily="34" charset="0"/>
+                <a:ea typeface="Calibri" pitchFamily="34" charset="-122"/>
+                <a:cs typeface="Calibri" pitchFamily="34" charset="-120"/>
+              </a:rPr>
+              <a:t>K3s Master Node</a:t>
+            </a:r>
+            <a:endParaRPr lang="en-US" sz="1000" dirty="0"/>
+          </a:p>
+          <a:p>
+            <a:pPr marL="0" indent="0">
+              <a:buNone/>
+            </a:pPr>
+            <a:r>
+              <a:rPr lang="en-US" sz="1000" dirty="0">
+                <a:solidFill>
+                  <a:srgbClr val="FFFFFF"/>
+                </a:solidFill>
+                <a:latin typeface="Calibri" pitchFamily="34" charset="0"/>
+                <a:ea typeface="Calibri" pitchFamily="34" charset="-122"/>
+                <a:cs typeface="Calibri" pitchFamily="34" charset="-120"/>
+              </a:rPr>
+              <a:t>API Server · etcd · Scheduler</a:t>
+            </a:r>
+            <a:endParaRPr lang="en-US" sz="1000" dirty="0"/>
+          </a:p>
+        </p:txBody>
+      </p:sp>
+      <p:sp>
+        <p:nvSpPr>
+          <p:cNvPr id="27" name="Text 24"/>
+          <p:cNvSpPr/>
+          <p:nvPr/>
+        </p:nvSpPr>
+        <p:spPr>
+          <a:xfrm>
+            <a:off x="6858000" y="2359152"/>
+            <a:ext cx="457200" cy="274320"/>
+          </a:xfrm>
+          <a:prstGeom prst="rect">
+            <a:avLst/>
+          </a:prstGeom>
+          <a:noFill/>
+          <a:ln/>
+        </p:spPr>
+        <p:txBody>
+          <a:bodyPr wrap="square" rtlCol="0" anchor="ctr"/>
+          <a:lstStyle/>
+          <a:p>
+            <a:pPr marL="0" indent="0" algn="ctr">
+              <a:buNone/>
+            </a:pPr>
+            <a:r>
+              <a:rPr lang="en-US" sz="1800" dirty="0">
+                <a:solidFill>
+                  <a:srgbClr val="2196F3"/>
+                </a:solidFill>
+                <a:latin typeface="Calibri" pitchFamily="34" charset="0"/>
+                <a:ea typeface="Calibri" pitchFamily="34" charset="-122"/>
+                <a:cs typeface="Calibri" pitchFamily="34" charset="-120"/>
+              </a:rPr>
+              <a:t>↓</a:t>
+            </a:r>
+            <a:endParaRPr lang="en-US" sz="1800" dirty="0"/>
+          </a:p>
+        </p:txBody>
+      </p:sp>
+      <p:sp>
+        <p:nvSpPr>
+          <p:cNvPr id="28" name="Shape 25"/>
+          <p:cNvSpPr/>
+          <p:nvPr/>
+        </p:nvSpPr>
+        <p:spPr>
+          <a:xfrm>
+            <a:off x="5943600" y="2697480"/>
+            <a:ext cx="2743200" cy="685800"/>
+          </a:xfrm>
+          <a:prstGeom prst="rect">
+            <a:avLst/>
+          </a:prstGeom>
+          <a:solidFill>
+            <a:srgbClr val="2196F3"/>
+          </a:solidFill>
+          <a:ln w="12700">
+            <a:solidFill>
+              <a:srgbClr val="2196F3"/>
+            </a:solidFill>
+            <a:prstDash val="solid"/>
+          </a:ln>
+          <a:effectLst>
+            <a:outerShdw blurRad="101600" dist="25400" dir="8100000" algn="bl" rotWithShape="0">
+              <a:srgbClr val="000000">
+                <a:alpha val="10000"/>
+              </a:srgbClr>
+            </a:outerShdw>
+          </a:effectLst>
+        </p:spPr>
+      </p:sp>
+      <p:pic>
+        <p:nvPicPr>
+          <p:cNvPr id="29" name="Image 1" descr="preencoded.png"/>
+          <p:cNvPicPr>
+            <a:picLocks noChangeAspect="1"/>
+          </p:cNvPicPr>
+          <p:nvPr/>
+        </p:nvPicPr>
+        <p:blipFill>
+          <a:blip r:embed="rId4"/>
+          <a:stretch>
+            <a:fillRect/>
+          </a:stretch>
+        </p:blipFill>
+        <p:spPr>
+          <a:xfrm>
+            <a:off x="5989320" y="2761488"/>
+            <a:ext cx="457200" cy="457200"/>
+          </a:xfrm>
+          <a:prstGeom prst="rect">
+            <a:avLst/>
+          </a:prstGeom>
+        </p:spPr>
+      </p:pic>
+      <p:sp>
+        <p:nvSpPr>
+          <p:cNvPr id="30" name="Text 26"/>
+          <p:cNvSpPr/>
+          <p:nvPr/>
+        </p:nvSpPr>
+        <p:spPr>
+          <a:xfrm>
+            <a:off x="6492240" y="2743200"/>
+            <a:ext cx="2103120" cy="548640"/>
+          </a:xfrm>
+          <a:prstGeom prst="rect">
+            <a:avLst/>
+          </a:prstGeom>
+          <a:noFill/>
+          <a:ln/>
+        </p:spPr>
+        <p:txBody>
+          <a:bodyPr wrap="square" lIns="0" tIns="0" rIns="0" bIns="0" rtlCol="0" anchor="ctr"/>
+          <a:lstStyle/>
+          <a:p>
+            <a:pPr marL="0" indent="0">
+              <a:buNone/>
+            </a:pPr>
+            <a:r>
+              <a:rPr lang="en-US" sz="1000" dirty="0">
+                <a:solidFill>
+                  <a:srgbClr val="FFFFFF"/>
+                </a:solidFill>
+                <a:latin typeface="Calibri" pitchFamily="34" charset="0"/>
+                <a:ea typeface="Calibri" pitchFamily="34" charset="-122"/>
+                <a:cs typeface="Calibri" pitchFamily="34" charset="-120"/>
+              </a:rPr>
+              <a:t>K3s Worker Node</a:t>
+            </a:r>
+            <a:endParaRPr lang="en-US" sz="1000" dirty="0"/>
+          </a:p>
+          <a:p>
+            <a:pPr marL="0" indent="0">
+              <a:buNone/>
+            </a:pPr>
+            <a:r>
+              <a:rPr lang="en-US" sz="1000" dirty="0">
+                <a:solidFill>
+                  <a:srgbClr val="FFFFFF"/>
+                </a:solidFill>
+                <a:latin typeface="Calibri" pitchFamily="34" charset="0"/>
+                <a:ea typeface="Calibri" pitchFamily="34" charset="-122"/>
+                <a:cs typeface="Calibri" pitchFamily="34" charset="-120"/>
+              </a:rPr>
+              <a:t>Container Runtime · kubelet</a:t>
+            </a:r>
+            <a:endParaRPr lang="en-US" sz="1000" dirty="0"/>
+          </a:p>
+        </p:txBody>
+      </p:sp>
+      <p:sp>
+        <p:nvSpPr>
+          <p:cNvPr id="31" name="Shape 27"/>
+          <p:cNvSpPr/>
+          <p:nvPr/>
+        </p:nvSpPr>
+        <p:spPr>
+          <a:xfrm>
+            <a:off x="6035040" y="3520440"/>
+            <a:ext cx="2560320" cy="548640"/>
+          </a:xfrm>
+          <a:prstGeom prst="rect">
+            <a:avLst/>
+          </a:prstGeom>
+          <a:solidFill>
+            <a:srgbClr val="E3F2FD"/>
+          </a:solidFill>
+          <a:ln w="12700">
+            <a:solidFill>
+              <a:srgbClr val="2196F3"/>
+            </a:solidFill>
+            <a:prstDash val="solid"/>
+          </a:ln>
+        </p:spPr>
+      </p:sp>
+      <p:pic>
+        <p:nvPicPr>
+          <p:cNvPr id="32" name="Image 2" descr="preencoded.png"/>
+          <p:cNvPicPr>
+            <a:picLocks noChangeAspect="1"/>
+          </p:cNvPicPr>
+          <p:nvPr/>
+        </p:nvPicPr>
+        <p:blipFill>
+          <a:blip r:embed="rId5"/>
+          <a:stretch>
+            <a:fillRect/>
+          </a:stretch>
+        </p:blipFill>
+        <p:spPr>
+          <a:xfrm>
+            <a:off x="6080760" y="3584448"/>
+            <a:ext cx="365760" cy="365760"/>
+          </a:xfrm>
+          <a:prstGeom prst="rect">
+            <a:avLst/>
+          </a:prstGeom>
+        </p:spPr>
+      </p:pic>
+      <p:sp>
+        <p:nvSpPr>
+          <p:cNvPr id="33" name="Text 28"/>
+          <p:cNvSpPr/>
+          <p:nvPr/>
+        </p:nvSpPr>
+        <p:spPr>
+          <a:xfrm>
+            <a:off x="6492240" y="3566160"/>
+            <a:ext cx="2011680" cy="438912"/>
+          </a:xfrm>
+          <a:prstGeom prst="rect">
+            <a:avLst/>
+          </a:prstGeom>
+          <a:noFill/>
+          <a:ln/>
+        </p:spPr>
+        <p:txBody>
+          <a:bodyPr wrap="square" lIns="0" tIns="0" rIns="0" bIns="0" rtlCol="0" anchor="ctr"/>
+          <a:lstStyle/>
+          <a:p>
+            <a:pPr marL="0" indent="0">
+              <a:buNone/>
+            </a:pPr>
+            <a:r>
+              <a:rPr lang="en-US" sz="1000" dirty="0">
+                <a:solidFill>
+                  <a:srgbClr val="1B3A6B"/>
+                </a:solidFill>
+                <a:latin typeface="Calibri" pitchFamily="34" charset="0"/>
+                <a:ea typeface="Calibri" pitchFamily="34" charset="-122"/>
+                <a:cs typeface="Calibri" pitchFamily="34" charset="-120"/>
+              </a:rPr>
+              <a:t>Pod: portfolio-container</a:t>
+            </a:r>
+            <a:endParaRPr lang="en-US" sz="1000" dirty="0"/>
+          </a:p>
+          <a:p>
+            <a:pPr marL="0" indent="0">
+              <a:buNone/>
+            </a:pPr>
+            <a:r>
+              <a:rPr lang="en-US" sz="1000" dirty="0">
+                <a:solidFill>
+                  <a:srgbClr val="1B3A6B"/>
+                </a:solidFill>
+                <a:latin typeface="Calibri" pitchFamily="34" charset="0"/>
+                <a:ea typeface="Calibri" pitchFamily="34" charset="-122"/>
+                <a:cs typeface="Calibri" pitchFamily="34" charset="-120"/>
+              </a:rPr>
+              <a:t>:30080</a:t>
             </a:r>
             <a:endParaRPr lang="en-US" sz="1000" dirty="0"/>
           </a:p>

</xml_diff>